<commit_message>
Presentacion: restaurar el contenido de la diapositiva de la Pregunta 2
</commit_message>
<xml_diff>
--- a/Entregables/Presentacion_Proyecto_1_INVIAS.pptx
+++ b/Entregables/Presentacion_Proyecto_1_INVIAS.pptx
@@ -4363,7 +4363,7 @@
             </a:pPr>
             <a:r>
               <a:rPr dirty="0"/>
-              <a:t>VISUALIZACIÓN TERRITORIAL PRINCIPAL</a:t>
+              <a:t>MÓDULO DE DISTRIBUCIÓN TERRITORIAL EN EL TABLERO</a:t>
             </a:r>
           </a:p>
         </p:txBody>
@@ -4459,7 +4459,7 @@
               </a:defRPr>
             </a:pPr>
             <a:r>
-              <a:t>[Cifra / hallazgo territorial]</a:t>
+              <a:t>43 % de los contratos puede ubicarse en un departamento, pero concentra el 77,9 % del valor. Lo no ubicable es el 56,7 % de los registros y solo el 22,1 % del dinero.</a:t>
             </a:r>
           </a:p>
         </p:txBody>
@@ -4555,7 +4555,7 @@
               </a:defRPr>
             </a:pPr>
             <a:r>
-              <a:t>[Cifra / hallazgo territorial]</a:t>
+              <a:t>La trazabilidad se está perdiendo: 85–95 % entre 2018 y 2022, 76 % en 2023 y 2024, y 46 % en 2025.</a:t>
             </a:r>
           </a:p>
         </p:txBody>
@@ -4651,7 +4651,7 @@
               </a:defRPr>
             </a:pPr>
             <a:r>
-              <a:t>[Una frase ejecutiva]</a:t>
+              <a:t>Uno de cada cinco pesos no es rastreable territorialmente desde lo que publica el SECOP II.</a:t>
             </a:r>
           </a:p>
         </p:txBody>
@@ -4713,7 +4713,7 @@
         </p:blipFill>
         <p:spPr>
           <a:xfrm>
-            <a:off x="1382268" y="1874520"/>
+            <a:off x="1382268" y="2057400"/>
             <a:ext cx="4883336" cy="3589020"/>
           </a:xfrm>
           <a:prstGeom prst="rect">

</xml_diff>

<commit_message>
Actualiza versión final de entregables
</commit_message>
<xml_diff>
--- a/Entregables/Presentacion_Proyecto_1_INVIAS.pptx
+++ b/Entregables/Presentacion_Proyecto_1_INVIAS.pptx
@@ -132,23 +132,110 @@
 <pc:chgInfo xmlns:a="http://schemas.openxmlformats.org/drawingml/2006/main" xmlns:r="http://schemas.openxmlformats.org/officeDocument/2006/relationships" xmlns:ac="http://schemas.microsoft.com/office/drawing/2013/main/command" xmlns:pc="http://schemas.microsoft.com/office/powerpoint/2013/main/command">
   <pc:docChgLst>
     <pc:chgData name="Edwin Calderón García" userId="2d031e888a90ae0e" providerId="LiveId" clId="{F30428A9-2CCB-5619-852C-C0A1C93BAE6D}"/>
-    <pc:docChg chg="modSld">
-      <pc:chgData name="Edwin Calderón García" userId="2d031e888a90ae0e" providerId="LiveId" clId="{F30428A9-2CCB-5619-852C-C0A1C93BAE6D}" dt="2026-09-14T20:40:01.017" v="12" actId="14100"/>
+    <pc:docChg chg="undo custSel modSld">
+      <pc:chgData name="Edwin Calderón García" userId="2d031e888a90ae0e" providerId="LiveId" clId="{F30428A9-2CCB-5619-852C-C0A1C93BAE6D}" dt="2026-09-15T00:40:08.704" v="121" actId="20577"/>
       <pc:docMkLst>
         <pc:docMk/>
       </pc:docMkLst>
+      <pc:sldChg chg="addSp delSp modSp mod">
+        <pc:chgData name="Edwin Calderón García" userId="2d031e888a90ae0e" providerId="LiveId" clId="{F30428A9-2CCB-5619-852C-C0A1C93BAE6D}" dt="2026-09-15T00:38:26.787" v="81" actId="1440"/>
+        <pc:sldMkLst>
+          <pc:docMk/>
+          <pc:sldMk cId="0" sldId="257"/>
+        </pc:sldMkLst>
+        <pc:spChg chg="mod">
+          <ac:chgData name="Edwin Calderón García" userId="2d031e888a90ae0e" providerId="LiveId" clId="{F30428A9-2CCB-5619-852C-C0A1C93BAE6D}" dt="2026-09-15T00:37:06.581" v="78" actId="123"/>
+          <ac:spMkLst>
+            <pc:docMk/>
+            <pc:sldMk cId="0" sldId="257"/>
+            <ac:spMk id="6" creationId="{00000000-0000-0000-0000-000000000000}"/>
+          </ac:spMkLst>
+        </pc:spChg>
+        <pc:spChg chg="mod">
+          <ac:chgData name="Edwin Calderón García" userId="2d031e888a90ae0e" providerId="LiveId" clId="{F30428A9-2CCB-5619-852C-C0A1C93BAE6D}" dt="2026-09-15T00:37:20.375" v="80" actId="123"/>
+          <ac:spMkLst>
+            <pc:docMk/>
+            <pc:sldMk cId="0" sldId="257"/>
+            <ac:spMk id="8" creationId="{00000000-0000-0000-0000-000000000000}"/>
+          </ac:spMkLst>
+        </pc:spChg>
+        <pc:spChg chg="del">
+          <ac:chgData name="Edwin Calderón García" userId="2d031e888a90ae0e" providerId="LiveId" clId="{F30428A9-2CCB-5619-852C-C0A1C93BAE6D}" dt="2026-09-15T00:36:23.881" v="73" actId="478"/>
+          <ac:spMkLst>
+            <pc:docMk/>
+            <pc:sldMk cId="0" sldId="257"/>
+            <ac:spMk id="11" creationId="{00000000-0000-0000-0000-000000000000}"/>
+          </ac:spMkLst>
+        </pc:spChg>
+        <pc:picChg chg="add mod">
+          <ac:chgData name="Edwin Calderón García" userId="2d031e888a90ae0e" providerId="LiveId" clId="{F30428A9-2CCB-5619-852C-C0A1C93BAE6D}" dt="2026-09-15T00:38:26.787" v="81" actId="1440"/>
+          <ac:picMkLst>
+            <pc:docMk/>
+            <pc:sldMk cId="0" sldId="257"/>
+            <ac:picMk id="13" creationId="{038A5DD4-2999-768C-C07A-AE60D3567394}"/>
+          </ac:picMkLst>
+        </pc:picChg>
+      </pc:sldChg>
       <pc:sldChg chg="addSp modSp mod">
-        <pc:chgData name="Edwin Calderón García" userId="2d031e888a90ae0e" providerId="LiveId" clId="{F30428A9-2CCB-5619-852C-C0A1C93BAE6D}" dt="2026-09-14T20:38:36.488" v="5" actId="1440"/>
+        <pc:chgData name="Edwin Calderón García" userId="2d031e888a90ae0e" providerId="LiveId" clId="{F30428A9-2CCB-5619-852C-C0A1C93BAE6D}" dt="2026-09-15T00:33:55.954" v="72" actId="6549"/>
         <pc:sldMkLst>
           <pc:docMk/>
           <pc:sldMk cId="0" sldId="258"/>
         </pc:sldMkLst>
+        <pc:spChg chg="mod">
+          <ac:chgData name="Edwin Calderón García" userId="2d031e888a90ae0e" providerId="LiveId" clId="{F30428A9-2CCB-5619-852C-C0A1C93BAE6D}" dt="2026-09-15T00:33:18.658" v="18" actId="1076"/>
+          <ac:spMkLst>
+            <pc:docMk/>
+            <pc:sldMk cId="0" sldId="258"/>
+            <ac:spMk id="2" creationId="{00000000-0000-0000-0000-000000000000}"/>
+          </ac:spMkLst>
+        </pc:spChg>
+        <pc:spChg chg="mod">
+          <ac:chgData name="Edwin Calderón García" userId="2d031e888a90ae0e" providerId="LiveId" clId="{F30428A9-2CCB-5619-852C-C0A1C93BAE6D}" dt="2026-09-15T00:33:55.954" v="72" actId="6549"/>
+          <ac:spMkLst>
+            <pc:docMk/>
+            <pc:sldMk cId="0" sldId="258"/>
+            <ac:spMk id="4" creationId="{00000000-0000-0000-0000-000000000000}"/>
+          </ac:spMkLst>
+        </pc:spChg>
         <pc:spChg chg="mod">
           <ac:chgData name="Edwin Calderón García" userId="2d031e888a90ae0e" providerId="LiveId" clId="{F30428A9-2CCB-5619-852C-C0A1C93BAE6D}" dt="2026-09-14T20:38:30.440" v="3" actId="1076"/>
           <ac:spMkLst>
             <pc:docMk/>
             <pc:sldMk cId="0" sldId="258"/>
             <ac:spMk id="6" creationId="{00000000-0000-0000-0000-000000000000}"/>
+          </ac:spMkLst>
+        </pc:spChg>
+        <pc:spChg chg="mod">
+          <ac:chgData name="Edwin Calderón García" userId="2d031e888a90ae0e" providerId="LiveId" clId="{F30428A9-2CCB-5619-852C-C0A1C93BAE6D}" dt="2026-09-15T00:33:28.656" v="21" actId="123"/>
+          <ac:spMkLst>
+            <pc:docMk/>
+            <pc:sldMk cId="0" sldId="258"/>
+            <ac:spMk id="8" creationId="{00000000-0000-0000-0000-000000000000}"/>
+          </ac:spMkLst>
+        </pc:spChg>
+        <pc:spChg chg="mod">
+          <ac:chgData name="Edwin Calderón García" userId="2d031e888a90ae0e" providerId="LiveId" clId="{F30428A9-2CCB-5619-852C-C0A1C93BAE6D}" dt="2026-09-15T00:33:26.508" v="20" actId="123"/>
+          <ac:spMkLst>
+            <pc:docMk/>
+            <pc:sldMk cId="0" sldId="258"/>
+            <ac:spMk id="10" creationId="{00000000-0000-0000-0000-000000000000}"/>
+          </ac:spMkLst>
+        </pc:spChg>
+        <pc:spChg chg="mod">
+          <ac:chgData name="Edwin Calderón García" userId="2d031e888a90ae0e" providerId="LiveId" clId="{F30428A9-2CCB-5619-852C-C0A1C93BAE6D}" dt="2026-09-15T00:33:13.858" v="16" actId="14100"/>
+          <ac:spMkLst>
+            <pc:docMk/>
+            <pc:sldMk cId="0" sldId="258"/>
+            <ac:spMk id="11" creationId="{00000000-0000-0000-0000-000000000000}"/>
+          </ac:spMkLst>
+        </pc:spChg>
+        <pc:spChg chg="mod">
+          <ac:chgData name="Edwin Calderón García" userId="2d031e888a90ae0e" providerId="LiveId" clId="{F30428A9-2CCB-5619-852C-C0A1C93BAE6D}" dt="2026-09-15T00:33:24.056" v="19" actId="123"/>
+          <ac:spMkLst>
+            <pc:docMk/>
+            <pc:sldMk cId="0" sldId="258"/>
+            <ac:spMk id="12" creationId="{00000000-0000-0000-0000-000000000000}"/>
           </ac:spMkLst>
         </pc:spChg>
         <pc:picChg chg="add mod">
@@ -159,6 +246,21 @@
             <ac:picMk id="14" creationId="{219C6468-D23B-32F9-49F2-8CA61769BD6B}"/>
           </ac:picMkLst>
         </pc:picChg>
+      </pc:sldChg>
+      <pc:sldChg chg="modSp mod">
+        <pc:chgData name="Edwin Calderón García" userId="2d031e888a90ae0e" providerId="LiveId" clId="{F30428A9-2CCB-5619-852C-C0A1C93BAE6D}" dt="2026-09-15T00:40:08.704" v="121" actId="20577"/>
+        <pc:sldMkLst>
+          <pc:docMk/>
+          <pc:sldMk cId="0" sldId="260"/>
+        </pc:sldMkLst>
+        <pc:spChg chg="mod">
+          <ac:chgData name="Edwin Calderón García" userId="2d031e888a90ae0e" providerId="LiveId" clId="{F30428A9-2CCB-5619-852C-C0A1C93BAE6D}" dt="2026-09-15T00:40:08.704" v="121" actId="20577"/>
+          <ac:spMkLst>
+            <pc:docMk/>
+            <pc:sldMk cId="0" sldId="260"/>
+            <ac:spMk id="15" creationId="{00000000-0000-0000-0000-000000000000}"/>
+          </ac:spMkLst>
+        </pc:spChg>
       </pc:sldChg>
       <pc:sldChg chg="addSp modSp mod">
         <pc:chgData name="Edwin Calderón García" userId="2d031e888a90ae0e" providerId="LiveId" clId="{F30428A9-2CCB-5619-852C-C0A1C93BAE6D}" dt="2026-09-14T20:40:01.017" v="12" actId="14100"/>
@@ -3856,7 +3958,7 @@
         <p:spPr>
           <a:xfrm>
             <a:off x="822959" y="1655063"/>
-            <a:ext cx="2834640" cy="1554480"/>
+            <a:ext cx="2834640" cy="1092607"/>
           </a:xfrm>
           <a:prstGeom prst="rect">
             <a:avLst/>
@@ -3877,11 +3979,12 @@
               </a:defRPr>
             </a:pPr>
             <a:r>
+              <a:rPr dirty="0"/>
               <a:t>CIFRA CLAVE</a:t>
             </a:r>
           </a:p>
           <a:p>
-            <a:pPr>
+            <a:pPr algn="just">
               <a:spcBef>
                 <a:spcPts val="600"/>
               </a:spcBef>
@@ -3892,8 +3995,14 @@
               </a:defRPr>
             </a:pPr>
             <a:r>
-              <a:t>[Insertar cifra principal de Pregunta 1]</a:t>
-            </a:r>
+              <a:rPr lang="es-CO" sz="1200" dirty="0">
+                <a:solidFill>
+                  <a:srgbClr val="232B32"/>
+                </a:solidFill>
+              </a:rPr>
+              <a:t>Los 10 principales proveedores concentran solo el 20,38 % del valor contratado y el HHI es cercano a 85 puntos, indicando baja concentración global por proveedor.</a:t>
+            </a:r>
+            <a:endParaRPr dirty="0"/>
           </a:p>
         </p:txBody>
       </p:sp>
@@ -3952,7 +4061,7 @@
         <p:spPr>
           <a:xfrm>
             <a:off x="822959" y="3666744"/>
-            <a:ext cx="2834640" cy="1554480"/>
+            <a:ext cx="2834640" cy="1461939"/>
           </a:xfrm>
           <a:prstGeom prst="rect">
             <a:avLst/>
@@ -3973,11 +4082,12 @@
               </a:defRPr>
             </a:pPr>
             <a:r>
+              <a:rPr dirty="0"/>
               <a:t>HALLAZGO</a:t>
             </a:r>
           </a:p>
           <a:p>
-            <a:pPr>
+            <a:pPr algn="just">
               <a:spcBef>
                 <a:spcPts val="600"/>
               </a:spcBef>
@@ -3988,8 +4098,14 @@
               </a:defRPr>
             </a:pPr>
             <a:r>
-              <a:t>[Insertar segundo hallazgo cuantitativo]</a:t>
-            </a:r>
+              <a:rPr lang="es-CO" sz="1200" dirty="0">
+                <a:solidFill>
+                  <a:srgbClr val="232B32"/>
+                </a:solidFill>
+              </a:rPr>
+              <a:t>La concentración cambia significativamente según el tipo y modalidad contractual: los contratos de Obra representan el 15,4 % de los contratos, pero concentran el 66,3 % del valor contratado.</a:t>
+            </a:r>
+            <a:endParaRPr dirty="0"/>
           </a:p>
         </p:txBody>
       </p:sp>
@@ -4076,14 +4192,14 @@
       </p:sp>
       <p:sp>
         <p:nvSpPr>
-          <p:cNvPr id="11" name="TextBox 10"/>
+          <p:cNvPr id="12" name="TextBox 11"/>
           <p:cNvSpPr txBox="1"/>
           <p:nvPr/>
         </p:nvSpPr>
         <p:spPr>
           <a:xfrm>
-            <a:off x="6845223" y="2788920"/>
-            <a:ext cx="1854354" cy="338554"/>
+            <a:off x="594360" y="6492240"/>
+            <a:ext cx="10972800" cy="182880"/>
           </a:xfrm>
           <a:prstGeom prst="rect">
             <a:avLst/>
@@ -4096,42 +4212,6 @@
           </a:bodyPr>
           <a:lstStyle/>
           <a:p>
-            <a:pPr algn="ctr">
-              <a:defRPr sz="1600" b="1">
-                <a:solidFill>
-                  <a:srgbClr val="2366AA"/>
-                </a:solidFill>
-              </a:defRPr>
-            </a:pPr>
-            <a:r>
-              <a:rPr dirty="0"/>
-              <a:t>INSIGHT EJECUTIVO</a:t>
-            </a:r>
-          </a:p>
-        </p:txBody>
-      </p:sp>
-      <p:sp>
-        <p:nvSpPr>
-          <p:cNvPr id="12" name="TextBox 11"/>
-          <p:cNvSpPr txBox="1"/>
-          <p:nvPr/>
-        </p:nvSpPr>
-        <p:spPr>
-          <a:xfrm>
-            <a:off x="594360" y="6492240"/>
-            <a:ext cx="10972800" cy="182880"/>
-          </a:xfrm>
-          <a:prstGeom prst="rect">
-            <a:avLst/>
-          </a:prstGeom>
-          <a:noFill/>
-        </p:spPr>
-        <p:txBody>
-          <a:bodyPr wrap="none">
-            <a:spAutoFit/>
-          </a:bodyPr>
-          <a:lstStyle/>
-          <a:p>
             <a:pPr>
               <a:defRPr sz="800">
                 <a:solidFill>
@@ -4145,558 +4225,12 @@
           </a:p>
         </p:txBody>
       </p:sp>
-    </p:spTree>
-  </p:cSld>
-  <p:clrMapOvr>
-    <a:masterClrMapping/>
-  </p:clrMapOvr>
-</p:sld>
-</file>
-
-<file path=ppt/slides/slide3.xml><?xml version="1.0" encoding="utf-8"?>
-<p:sld xmlns:a="http://schemas.openxmlformats.org/drawingml/2006/main" xmlns:r="http://schemas.openxmlformats.org/officeDocument/2006/relationships" xmlns:p="http://schemas.openxmlformats.org/presentationml/2006/main">
-  <p:cSld>
-    <p:spTree>
-      <p:nvGrpSpPr>
-        <p:cNvPr id="1" name=""/>
-        <p:cNvGrpSpPr/>
-        <p:nvPr/>
-      </p:nvGrpSpPr>
-      <p:grpSpPr>
-        <a:xfrm>
-          <a:off x="0" y="0"/>
-          <a:ext cx="0" cy="0"/>
-          <a:chOff x="0" y="0"/>
-          <a:chExt cx="0" cy="0"/>
-        </a:xfrm>
-      </p:grpSpPr>
-      <p:sp>
-        <p:nvSpPr>
-          <p:cNvPr id="2" name="Rectangle 1"/>
-          <p:cNvSpPr/>
-          <p:nvPr/>
-        </p:nvSpPr>
-        <p:spPr>
-          <a:xfrm>
-            <a:off x="0" y="0"/>
-            <a:ext cx="12191695" cy="6858000"/>
-          </a:xfrm>
-          <a:prstGeom prst="rect">
-            <a:avLst/>
-          </a:prstGeom>
-          <a:solidFill>
-            <a:srgbClr val="FFFFFF"/>
-          </a:solidFill>
-          <a:ln>
-            <a:noFill/>
-          </a:ln>
-        </p:spPr>
-        <p:style>
-          <a:lnRef idx="1">
-            <a:schemeClr val="accent1"/>
-          </a:lnRef>
-          <a:fillRef idx="3">
-            <a:schemeClr val="accent1"/>
-          </a:fillRef>
-          <a:effectRef idx="2">
-            <a:schemeClr val="accent1"/>
-          </a:effectRef>
-          <a:fontRef idx="minor">
-            <a:schemeClr val="lt1"/>
-          </a:fontRef>
-        </p:style>
-        <p:txBody>
-          <a:bodyPr rtlCol="0" anchor="ctr"/>
-          <a:lstStyle/>
-          <a:p>
-            <a:pPr algn="ctr"/>
-            <a:endParaRPr/>
-          </a:p>
-        </p:txBody>
-      </p:sp>
-      <p:sp>
-        <p:nvSpPr>
-          <p:cNvPr id="3" name="TextBox 2"/>
-          <p:cNvSpPr txBox="1"/>
-          <p:nvPr/>
-        </p:nvSpPr>
-        <p:spPr>
-          <a:xfrm>
-            <a:off x="594360" y="320040"/>
-            <a:ext cx="10972800" cy="594360"/>
-          </a:xfrm>
-          <a:prstGeom prst="rect">
-            <a:avLst/>
-          </a:prstGeom>
-          <a:noFill/>
-        </p:spPr>
-        <p:txBody>
-          <a:bodyPr wrap="none">
-            <a:spAutoFit/>
-          </a:bodyPr>
-          <a:lstStyle/>
-          <a:p>
-            <a:pPr>
-              <a:defRPr sz="2700" b="1">
-                <a:solidFill>
-                  <a:srgbClr val="123052"/>
-                </a:solidFill>
-                <a:latin typeface="Aptos Display"/>
-              </a:defRPr>
-            </a:pPr>
-            <a:r>
-              <a:t>02 | Distribución y trazabilidad territorial</a:t>
-            </a:r>
-          </a:p>
-        </p:txBody>
-      </p:sp>
-      <p:sp>
-        <p:nvSpPr>
-          <p:cNvPr id="4" name="TextBox 3"/>
-          <p:cNvSpPr txBox="1"/>
-          <p:nvPr/>
-        </p:nvSpPr>
-        <p:spPr>
-          <a:xfrm>
-            <a:off x="612648" y="914400"/>
-            <a:ext cx="10789920" cy="365760"/>
-          </a:xfrm>
-          <a:prstGeom prst="rect">
-            <a:avLst/>
-          </a:prstGeom>
-          <a:noFill/>
-        </p:spPr>
-        <p:txBody>
-          <a:bodyPr wrap="none">
-            <a:spAutoFit/>
-          </a:bodyPr>
-          <a:lstStyle/>
-          <a:p>
-            <a:pPr>
-              <a:defRPr sz="1200">
-                <a:solidFill>
-                  <a:srgbClr val="647382"/>
-                </a:solidFill>
-                <a:latin typeface="Aptos"/>
-              </a:defRPr>
-            </a:pPr>
-            <a:r>
-              <a:t>¿Dónde se concentran los recursos y qué nivel de trazabilidad territorial puede obtenerse?</a:t>
-            </a:r>
-          </a:p>
-        </p:txBody>
-      </p:sp>
-      <p:sp>
-        <p:nvSpPr>
-          <p:cNvPr id="5" name="Rounded Rectangle 4"/>
-          <p:cNvSpPr/>
-          <p:nvPr/>
-        </p:nvSpPr>
-        <p:spPr>
-          <a:xfrm>
-            <a:off x="640080" y="1417320"/>
-            <a:ext cx="6583680" cy="4251960"/>
-          </a:xfrm>
-          <a:prstGeom prst="roundRect">
-            <a:avLst/>
-          </a:prstGeom>
-          <a:solidFill>
-            <a:srgbClr val="F2F5F8"/>
-          </a:solidFill>
-          <a:ln>
-            <a:solidFill>
-              <a:srgbClr val="E1E6EB"/>
-            </a:solidFill>
-          </a:ln>
-        </p:spPr>
-        <p:style>
-          <a:lnRef idx="1">
-            <a:schemeClr val="accent1"/>
-          </a:lnRef>
-          <a:fillRef idx="3">
-            <a:schemeClr val="accent1"/>
-          </a:fillRef>
-          <a:effectRef idx="2">
-            <a:schemeClr val="accent1"/>
-          </a:effectRef>
-          <a:fontRef idx="minor">
-            <a:schemeClr val="lt1"/>
-          </a:fontRef>
-        </p:style>
-        <p:txBody>
-          <a:bodyPr rtlCol="0" anchor="ctr"/>
-          <a:lstStyle/>
-          <a:p>
-            <a:pPr algn="ctr"/>
-            <a:endParaRPr/>
-          </a:p>
-        </p:txBody>
-      </p:sp>
-      <p:sp>
-        <p:nvSpPr>
-          <p:cNvPr id="6" name="TextBox 5"/>
-          <p:cNvSpPr txBox="1"/>
-          <p:nvPr/>
-        </p:nvSpPr>
-        <p:spPr>
-          <a:xfrm>
-            <a:off x="914400" y="1577340"/>
-            <a:ext cx="6035040" cy="320040"/>
-          </a:xfrm>
-          <a:prstGeom prst="rect">
-            <a:avLst/>
-          </a:prstGeom>
-          <a:noFill/>
-        </p:spPr>
-        <p:txBody>
-          <a:bodyPr wrap="none">
-            <a:spAutoFit/>
-          </a:bodyPr>
-          <a:lstStyle/>
-          <a:p>
-            <a:pPr>
-              <a:defRPr sz="1400" b="1">
-                <a:solidFill>
-                  <a:srgbClr val="123052"/>
-                </a:solidFill>
-              </a:defRPr>
-            </a:pPr>
-            <a:r>
-              <a:rPr dirty="0"/>
-              <a:t>VISUALIZACIÓN TERRITORIAL PRINCIPAL</a:t>
-            </a:r>
-          </a:p>
-        </p:txBody>
-      </p:sp>
-      <p:sp>
-        <p:nvSpPr>
-          <p:cNvPr id="7" name="Rounded Rectangle 6"/>
-          <p:cNvSpPr/>
-          <p:nvPr/>
-        </p:nvSpPr>
-        <p:spPr>
-          <a:xfrm>
-            <a:off x="7543800" y="1417320"/>
-            <a:ext cx="3931920" cy="1508760"/>
-          </a:xfrm>
-          <a:prstGeom prst="roundRect">
-            <a:avLst/>
-          </a:prstGeom>
-          <a:solidFill>
-            <a:srgbClr val="F2F5F8"/>
-          </a:solidFill>
-          <a:ln>
-            <a:solidFill>
-              <a:srgbClr val="E1E6EB"/>
-            </a:solidFill>
-          </a:ln>
-        </p:spPr>
-        <p:style>
-          <a:lnRef idx="1">
-            <a:schemeClr val="accent1"/>
-          </a:lnRef>
-          <a:fillRef idx="3">
-            <a:schemeClr val="accent1"/>
-          </a:fillRef>
-          <a:effectRef idx="2">
-            <a:schemeClr val="accent1"/>
-          </a:effectRef>
-          <a:fontRef idx="minor">
-            <a:schemeClr val="lt1"/>
-          </a:fontRef>
-        </p:style>
-        <p:txBody>
-          <a:bodyPr rtlCol="0" anchor="ctr"/>
-          <a:lstStyle/>
-          <a:p>
-            <a:pPr algn="ctr"/>
-            <a:endParaRPr/>
-          </a:p>
-        </p:txBody>
-      </p:sp>
-      <p:sp>
-        <p:nvSpPr>
-          <p:cNvPr id="8" name="TextBox 7"/>
-          <p:cNvSpPr txBox="1"/>
-          <p:nvPr/>
-        </p:nvSpPr>
-        <p:spPr>
-          <a:xfrm>
-            <a:off x="7726679" y="1563624"/>
-            <a:ext cx="3566160" cy="1234439"/>
-          </a:xfrm>
-          <a:prstGeom prst="rect">
-            <a:avLst/>
-          </a:prstGeom>
-          <a:noFill/>
-        </p:spPr>
-        <p:txBody>
-          <a:bodyPr wrap="square">
-            <a:spAutoFit/>
-          </a:bodyPr>
-          <a:lstStyle/>
-          <a:p>
-            <a:pPr>
-              <a:defRPr sz="1200" b="1">
-                <a:solidFill>
-                  <a:srgbClr val="2366AA"/>
-                </a:solidFill>
-              </a:defRPr>
-            </a:pPr>
-            <a:r>
-              <a:t>HALLAZGO 01</a:t>
-            </a:r>
-          </a:p>
-          <a:p>
-            <a:pPr>
-              <a:spcBef>
-                <a:spcPts val="600"/>
-              </a:spcBef>
-              <a:defRPr sz="1200">
-                <a:solidFill>
-                  <a:srgbClr val="232B32"/>
-                </a:solidFill>
-              </a:defRPr>
-            </a:pPr>
-            <a:r>
-              <a:t>[Cifra / hallazgo territorial]</a:t>
-            </a:r>
-          </a:p>
-        </p:txBody>
-      </p:sp>
-      <p:sp>
-        <p:nvSpPr>
-          <p:cNvPr id="9" name="Rounded Rectangle 8"/>
-          <p:cNvSpPr/>
-          <p:nvPr/>
-        </p:nvSpPr>
-        <p:spPr>
-          <a:xfrm>
-            <a:off x="7543800" y="3108960"/>
-            <a:ext cx="3931920" cy="1508760"/>
-          </a:xfrm>
-          <a:prstGeom prst="roundRect">
-            <a:avLst/>
-          </a:prstGeom>
-          <a:solidFill>
-            <a:srgbClr val="F2F5F8"/>
-          </a:solidFill>
-          <a:ln>
-            <a:solidFill>
-              <a:srgbClr val="E1E6EB"/>
-            </a:solidFill>
-          </a:ln>
-        </p:spPr>
-        <p:style>
-          <a:lnRef idx="1">
-            <a:schemeClr val="accent1"/>
-          </a:lnRef>
-          <a:fillRef idx="3">
-            <a:schemeClr val="accent1"/>
-          </a:fillRef>
-          <a:effectRef idx="2">
-            <a:schemeClr val="accent1"/>
-          </a:effectRef>
-          <a:fontRef idx="minor">
-            <a:schemeClr val="lt1"/>
-          </a:fontRef>
-        </p:style>
-        <p:txBody>
-          <a:bodyPr rtlCol="0" anchor="ctr"/>
-          <a:lstStyle/>
-          <a:p>
-            <a:pPr algn="ctr"/>
-            <a:endParaRPr/>
-          </a:p>
-        </p:txBody>
-      </p:sp>
-      <p:sp>
-        <p:nvSpPr>
-          <p:cNvPr id="10" name="TextBox 9"/>
-          <p:cNvSpPr txBox="1"/>
-          <p:nvPr/>
-        </p:nvSpPr>
-        <p:spPr>
-          <a:xfrm>
-            <a:off x="7726679" y="3255264"/>
-            <a:ext cx="3566160" cy="1234439"/>
-          </a:xfrm>
-          <a:prstGeom prst="rect">
-            <a:avLst/>
-          </a:prstGeom>
-          <a:noFill/>
-        </p:spPr>
-        <p:txBody>
-          <a:bodyPr wrap="square">
-            <a:spAutoFit/>
-          </a:bodyPr>
-          <a:lstStyle/>
-          <a:p>
-            <a:pPr>
-              <a:defRPr sz="1200" b="1">
-                <a:solidFill>
-                  <a:srgbClr val="2366AA"/>
-                </a:solidFill>
-              </a:defRPr>
-            </a:pPr>
-            <a:r>
-              <a:t>HALLAZGO 02</a:t>
-            </a:r>
-          </a:p>
-          <a:p>
-            <a:pPr>
-              <a:spcBef>
-                <a:spcPts val="600"/>
-              </a:spcBef>
-              <a:defRPr sz="1200">
-                <a:solidFill>
-                  <a:srgbClr val="232B32"/>
-                </a:solidFill>
-              </a:defRPr>
-            </a:pPr>
-            <a:r>
-              <a:t>[Cifra / hallazgo territorial]</a:t>
-            </a:r>
-          </a:p>
-        </p:txBody>
-      </p:sp>
-      <p:sp>
-        <p:nvSpPr>
-          <p:cNvPr id="11" name="Rounded Rectangle 10"/>
-          <p:cNvSpPr/>
-          <p:nvPr/>
-        </p:nvSpPr>
-        <p:spPr>
-          <a:xfrm>
-            <a:off x="7543800" y="4800600"/>
-            <a:ext cx="3931920" cy="868680"/>
-          </a:xfrm>
-          <a:prstGeom prst="roundRect">
-            <a:avLst/>
-          </a:prstGeom>
-          <a:solidFill>
-            <a:srgbClr val="F2F5F8"/>
-          </a:solidFill>
-          <a:ln>
-            <a:solidFill>
-              <a:srgbClr val="E1E6EB"/>
-            </a:solidFill>
-          </a:ln>
-        </p:spPr>
-        <p:style>
-          <a:lnRef idx="1">
-            <a:schemeClr val="accent1"/>
-          </a:lnRef>
-          <a:fillRef idx="3">
-            <a:schemeClr val="accent1"/>
-          </a:fillRef>
-          <a:effectRef idx="2">
-            <a:schemeClr val="accent1"/>
-          </a:effectRef>
-          <a:fontRef idx="minor">
-            <a:schemeClr val="lt1"/>
-          </a:fontRef>
-        </p:style>
-        <p:txBody>
-          <a:bodyPr rtlCol="0" anchor="ctr"/>
-          <a:lstStyle/>
-          <a:p>
-            <a:pPr algn="ctr"/>
-            <a:endParaRPr/>
-          </a:p>
-        </p:txBody>
-      </p:sp>
-      <p:sp>
-        <p:nvSpPr>
-          <p:cNvPr id="12" name="TextBox 11"/>
-          <p:cNvSpPr txBox="1"/>
-          <p:nvPr/>
-        </p:nvSpPr>
-        <p:spPr>
-          <a:xfrm>
-            <a:off x="7726679" y="4946904"/>
-            <a:ext cx="3566160" cy="594359"/>
-          </a:xfrm>
-          <a:prstGeom prst="rect">
-            <a:avLst/>
-          </a:prstGeom>
-          <a:noFill/>
-        </p:spPr>
-        <p:txBody>
-          <a:bodyPr wrap="square">
-            <a:spAutoFit/>
-          </a:bodyPr>
-          <a:lstStyle/>
-          <a:p>
-            <a:pPr>
-              <a:defRPr sz="1200" b="1">
-                <a:solidFill>
-                  <a:srgbClr val="DC872D"/>
-                </a:solidFill>
-              </a:defRPr>
-            </a:pPr>
-            <a:r>
-              <a:t>IMPLICACIÓN</a:t>
-            </a:r>
-          </a:p>
-          <a:p>
-            <a:pPr>
-              <a:spcBef>
-                <a:spcPts val="600"/>
-              </a:spcBef>
-              <a:defRPr sz="1200">
-                <a:solidFill>
-                  <a:srgbClr val="232B32"/>
-                </a:solidFill>
-              </a:defRPr>
-            </a:pPr>
-            <a:r>
-              <a:t>[Una frase ejecutiva]</a:t>
-            </a:r>
-          </a:p>
-        </p:txBody>
-      </p:sp>
-      <p:sp>
-        <p:nvSpPr>
-          <p:cNvPr id="13" name="TextBox 12"/>
-          <p:cNvSpPr txBox="1"/>
-          <p:nvPr/>
-        </p:nvSpPr>
-        <p:spPr>
-          <a:xfrm>
-            <a:off x="594360" y="6492240"/>
-            <a:ext cx="10972800" cy="182880"/>
-          </a:xfrm>
-          <a:prstGeom prst="rect">
-            <a:avLst/>
-          </a:prstGeom>
-          <a:noFill/>
-        </p:spPr>
-        <p:txBody>
-          <a:bodyPr wrap="none">
-            <a:spAutoFit/>
-          </a:bodyPr>
-          <a:lstStyle/>
-          <a:p>
-            <a:pPr>
-              <a:defRPr sz="800">
-                <a:solidFill>
-                  <a:srgbClr val="647382"/>
-                </a:solidFill>
-              </a:defRPr>
-            </a:pPr>
-            <a:r>
-              <a:t>Proyecto 1 | INVIAS | Universidad de los Andes</a:t>
-            </a:r>
-          </a:p>
-        </p:txBody>
-      </p:sp>
       <p:pic>
         <p:nvPicPr>
-          <p:cNvPr id="14" name="Imagen 13">
+          <p:cNvPr id="13" name="Imagen 12">
             <a:extLst>
               <a:ext uri="{FF2B5EF4-FFF2-40B4-BE49-F238E27FC236}">
-                <a16:creationId xmlns:a16="http://schemas.microsoft.com/office/drawing/2014/main" id="{219C6468-D23B-32F9-49F2-8CA61769BD6B}"/>
+                <a16:creationId xmlns:a16="http://schemas.microsoft.com/office/drawing/2014/main" id="{038A5DD4-2999-768C-C07A-AE60D3567394}"/>
               </a:ext>
             </a:extLst>
           </p:cNvPr>
@@ -4713,8 +4247,8 @@
         </p:blipFill>
         <p:spPr>
           <a:xfrm>
-            <a:off x="1382268" y="1874520"/>
-            <a:ext cx="4883336" cy="3589020"/>
+            <a:off x="4895616" y="2129246"/>
+            <a:ext cx="6035817" cy="2952629"/>
           </a:xfrm>
           <a:prstGeom prst="rect">
             <a:avLst/>
@@ -4759,7 +4293,7 @@
 </p:sld>
 </file>
 
-<file path=ppt/slides/slide4.xml><?xml version="1.0" encoding="utf-8"?>
+<file path=ppt/slides/slide3.xml><?xml version="1.0" encoding="utf-8"?>
 <p:sld xmlns:a="http://schemas.openxmlformats.org/drawingml/2006/main" xmlns:r="http://schemas.openxmlformats.org/officeDocument/2006/relationships" xmlns:p="http://schemas.openxmlformats.org/presentationml/2006/main">
   <p:cSld>
     <p:spTree>
@@ -4778,14 +4312,58 @@
       </p:grpSpPr>
       <p:sp>
         <p:nvSpPr>
-          <p:cNvPr id="16" name="TextBox 15"/>
+          <p:cNvPr id="2" name="Rectangle 1"/>
+          <p:cNvSpPr/>
+          <p:nvPr/>
+        </p:nvSpPr>
+        <p:spPr>
+          <a:xfrm>
+            <a:off x="0" y="0"/>
+            <a:ext cx="12191695" cy="6858000"/>
+          </a:xfrm>
+          <a:prstGeom prst="rect">
+            <a:avLst/>
+          </a:prstGeom>
+          <a:solidFill>
+            <a:srgbClr val="FFFFFF"/>
+          </a:solidFill>
+          <a:ln>
+            <a:noFill/>
+          </a:ln>
+        </p:spPr>
+        <p:style>
+          <a:lnRef idx="1">
+            <a:schemeClr val="accent1"/>
+          </a:lnRef>
+          <a:fillRef idx="3">
+            <a:schemeClr val="accent1"/>
+          </a:fillRef>
+          <a:effectRef idx="2">
+            <a:schemeClr val="accent1"/>
+          </a:effectRef>
+          <a:fontRef idx="minor">
+            <a:schemeClr val="lt1"/>
+          </a:fontRef>
+        </p:style>
+        <p:txBody>
+          <a:bodyPr rtlCol="0" anchor="ctr"/>
+          <a:lstStyle/>
+          <a:p>
+            <a:pPr algn="ctr"/>
+            <a:endParaRPr/>
+          </a:p>
+        </p:txBody>
+      </p:sp>
+      <p:sp>
+        <p:nvSpPr>
+          <p:cNvPr id="3" name="TextBox 2"/>
           <p:cNvSpPr txBox="1"/>
           <p:nvPr/>
         </p:nvSpPr>
         <p:spPr>
           <a:xfrm>
-            <a:off x="594360" y="6492240"/>
-            <a:ext cx="10972800" cy="182880"/>
+            <a:off x="594360" y="320040"/>
+            <a:ext cx="10972800" cy="594360"/>
           </a:xfrm>
           <a:prstGeom prst="rect">
             <a:avLst/>
@@ -4799,28 +4377,29 @@
           <a:lstStyle/>
           <a:p>
             <a:pPr>
-              <a:defRPr sz="800">
-                <a:solidFill>
-                  <a:srgbClr val="647382"/>
-                </a:solidFill>
+              <a:defRPr sz="2700" b="1">
+                <a:solidFill>
+                  <a:srgbClr val="123052"/>
+                </a:solidFill>
+                <a:latin typeface="Aptos Display"/>
               </a:defRPr>
             </a:pPr>
             <a:r>
-              <a:t>Proyecto 1 | INVIAS | Universidad de los Andes</a:t>
-            </a:r>
-          </a:p>
-        </p:txBody>
-      </p:sp>
-      <p:sp>
-        <p:nvSpPr>
-          <p:cNvPr id="17" name="TextBox 16"/>
+              <a:t>02 | Distribución y trazabilidad territorial</a:t>
+            </a:r>
+          </a:p>
+        </p:txBody>
+      </p:sp>
+      <p:sp>
+        <p:nvSpPr>
+          <p:cNvPr id="4" name="TextBox 3"/>
           <p:cNvSpPr txBox="1"/>
           <p:nvPr/>
         </p:nvSpPr>
         <p:spPr>
           <a:xfrm>
-            <a:off x="594360" y="320040"/>
-            <a:ext cx="10972800" cy="594360"/>
+            <a:off x="612648" y="914400"/>
+            <a:ext cx="5731505" cy="276999"/>
           </a:xfrm>
           <a:prstGeom prst="rect">
             <a:avLst/>
@@ -4834,65 +4413,62 @@
           <a:lstStyle/>
           <a:p>
             <a:pPr>
-              <a:defRPr sz="2700" b="1">
-                <a:solidFill>
-                  <a:srgbClr val="123052"/>
-                </a:solidFill>
-                <a:latin typeface="Aptos Display"/>
+              <a:defRPr sz="1200">
+                <a:solidFill>
+                  <a:srgbClr val="647382"/>
+                </a:solidFill>
+                <a:latin typeface="Aptos"/>
               </a:defRPr>
             </a:pPr>
             <a:r>
-              <a:t>03 | Ejecución financiera y modificaciones</a:t>
-            </a:r>
-          </a:p>
-        </p:txBody>
-      </p:sp>
-      <p:sp>
-        <p:nvSpPr>
-          <p:cNvPr id="18" name="TextBox 17"/>
-          <p:cNvSpPr txBox="1"/>
-          <p:nvPr/>
-        </p:nvSpPr>
-        <p:spPr>
-          <a:xfrm>
-            <a:off x="612648" y="914400"/>
-            <a:ext cx="10789920" cy="365760"/>
-          </a:xfrm>
-          <a:prstGeom prst="rect">
-            <a:avLst/>
-          </a:prstGeom>
-          <a:noFill/>
-        </p:spPr>
-        <p:txBody>
-          <a:bodyPr wrap="none">
-            <a:spAutoFit/>
-          </a:bodyPr>
-          <a:lstStyle/>
-          <a:p>
-            <a:pPr>
-              <a:defRPr sz="1200">
-                <a:solidFill>
-                  <a:srgbClr val="647382"/>
-                </a:solidFill>
-                <a:latin typeface="Aptos"/>
-              </a:defRPr>
-            </a:pPr>
-            <a:r>
-              <a:t>¿Dónde debemos focalizar el seguimiento?</a:t>
-            </a:r>
-          </a:p>
-        </p:txBody>
-      </p:sp>
-      <p:sp>
-        <p:nvSpPr>
-          <p:cNvPr id="19" name="Rounded Rectangle 18"/>
+              <a:rPr dirty="0"/>
+              <a:t>¿</a:t>
+            </a:r>
+            <a:r>
+              <a:rPr dirty="0" err="1"/>
+              <a:t>Dónde</a:t>
+            </a:r>
+            <a:r>
+              <a:rPr dirty="0"/>
+              <a:t> se </a:t>
+            </a:r>
+            <a:r>
+              <a:rPr dirty="0" err="1"/>
+              <a:t>concentran</a:t>
+            </a:r>
+            <a:r>
+              <a:rPr dirty="0"/>
+              <a:t> los </a:t>
+            </a:r>
+            <a:r>
+              <a:rPr dirty="0" err="1"/>
+              <a:t>recursos</a:t>
+            </a:r>
+            <a:r>
+              <a:rPr dirty="0"/>
+              <a:t> y </a:t>
+            </a:r>
+            <a:r>
+              <a:rPr lang="es-419" dirty="0"/>
+              <a:t>qué tan trazable es su ejecución </a:t>
+            </a:r>
+            <a:r>
+              <a:rPr dirty="0"/>
+              <a:t>territorial?</a:t>
+            </a:r>
+          </a:p>
+        </p:txBody>
+      </p:sp>
+      <p:sp>
+        <p:nvSpPr>
+          <p:cNvPr id="5" name="Rounded Rectangle 4"/>
           <p:cNvSpPr/>
           <p:nvPr/>
         </p:nvSpPr>
         <p:spPr>
           <a:xfrm>
-            <a:off x="640080" y="1298448"/>
-            <a:ext cx="3429000" cy="1024128"/>
+            <a:off x="640080" y="1417320"/>
+            <a:ext cx="6583680" cy="4251960"/>
           </a:xfrm>
           <a:prstGeom prst="roundRect">
             <a:avLst/>
@@ -4931,14 +4507,14 @@
       </p:sp>
       <p:sp>
         <p:nvSpPr>
-          <p:cNvPr id="20" name="TextBox 19"/>
+          <p:cNvPr id="6" name="TextBox 5"/>
           <p:cNvSpPr txBox="1"/>
           <p:nvPr/>
         </p:nvSpPr>
         <p:spPr>
           <a:xfrm>
-            <a:off x="777240" y="1417319"/>
-            <a:ext cx="3154680" cy="795528"/>
+            <a:off x="914400" y="1577340"/>
+            <a:ext cx="6035040" cy="320040"/>
           </a:xfrm>
           <a:prstGeom prst="rect">
             <a:avLst/>
@@ -4951,41 +4527,30 @@
           </a:bodyPr>
           <a:lstStyle/>
           <a:p>
-            <a:pPr algn="ctr">
-              <a:defRPr sz="2400" b="1">
-                <a:solidFill>
-                  <a:srgbClr val="2366AA"/>
+            <a:pPr>
+              <a:defRPr sz="1400" b="1">
+                <a:solidFill>
+                  <a:srgbClr val="123052"/>
                 </a:solidFill>
               </a:defRPr>
             </a:pPr>
             <a:r>
-              <a:t>20.718</a:t>
-            </a:r>
-          </a:p>
-          <a:p>
-            <a:pPr algn="ctr">
-              <a:defRPr sz="1000">
-                <a:solidFill>
-                  <a:srgbClr val="232B32"/>
-                </a:solidFill>
-              </a:defRPr>
-            </a:pPr>
-            <a:r>
-              <a:t>contratos analizados</a:t>
-            </a:r>
-          </a:p>
-        </p:txBody>
-      </p:sp>
-      <p:sp>
-        <p:nvSpPr>
-          <p:cNvPr id="21" name="Rounded Rectangle 20"/>
+              <a:rPr dirty="0"/>
+              <a:t>VISUALIZACIÓN TERRITORIAL PRINCIPAL</a:t>
+            </a:r>
+          </a:p>
+        </p:txBody>
+      </p:sp>
+      <p:sp>
+        <p:nvSpPr>
+          <p:cNvPr id="7" name="Rounded Rectangle 6"/>
           <p:cNvSpPr/>
           <p:nvPr/>
         </p:nvSpPr>
         <p:spPr>
           <a:xfrm>
-            <a:off x="4370832" y="1298448"/>
-            <a:ext cx="3429000" cy="1024128"/>
+            <a:off x="7543800" y="1417320"/>
+            <a:ext cx="3931920" cy="1508760"/>
           </a:xfrm>
           <a:prstGeom prst="roundRect">
             <a:avLst/>
@@ -5024,14 +4589,14 @@
       </p:sp>
       <p:sp>
         <p:nvSpPr>
-          <p:cNvPr id="22" name="TextBox 21"/>
+          <p:cNvPr id="8" name="TextBox 7"/>
           <p:cNvSpPr txBox="1"/>
           <p:nvPr/>
         </p:nvSpPr>
         <p:spPr>
           <a:xfrm>
-            <a:off x="4507992" y="1417319"/>
-            <a:ext cx="3154680" cy="795528"/>
+            <a:off x="7726679" y="1563624"/>
+            <a:ext cx="3566160" cy="1092607"/>
           </a:xfrm>
           <a:prstGeom prst="rect">
             <a:avLst/>
@@ -5039,46 +4604,56 @@
           <a:noFill/>
         </p:spPr>
         <p:txBody>
-          <a:bodyPr wrap="none">
+          <a:bodyPr wrap="square">
             <a:spAutoFit/>
           </a:bodyPr>
           <a:lstStyle/>
           <a:p>
-            <a:pPr algn="ctr">
-              <a:defRPr sz="2400" b="1">
-                <a:solidFill>
-                  <a:srgbClr val="DC872D"/>
+            <a:pPr>
+              <a:defRPr sz="1200" b="1">
+                <a:solidFill>
+                  <a:srgbClr val="2366AA"/>
                 </a:solidFill>
               </a:defRPr>
             </a:pPr>
             <a:r>
-              <a:t>54,6 %</a:t>
-            </a:r>
-          </a:p>
-          <a:p>
-            <a:pPr algn="ctr">
-              <a:defRPr sz="1000">
+              <a:rPr dirty="0"/>
+              <a:t>HALLAZGO 01</a:t>
+            </a:r>
+          </a:p>
+          <a:p>
+            <a:pPr algn="just">
+              <a:spcBef>
+                <a:spcPts val="600"/>
+              </a:spcBef>
+              <a:defRPr sz="1200">
                 <a:solidFill>
                   <a:srgbClr val="232B32"/>
                 </a:solidFill>
               </a:defRPr>
             </a:pPr>
             <a:r>
-              <a:t>con 0 % de ejecución registrada</a:t>
-            </a:r>
-          </a:p>
-        </p:txBody>
-      </p:sp>
-      <p:sp>
-        <p:nvSpPr>
-          <p:cNvPr id="23" name="Rounded Rectangle 22"/>
+              <a:rPr lang="es-CO" sz="1200" dirty="0">
+                <a:solidFill>
+                  <a:srgbClr val="232B32"/>
+                </a:solidFill>
+              </a:rPr>
+              <a:t>El 77,9% del valor contratado ($39,1 billones) puede ubicarse territorialmente en 33 departamentos, permitiendo identificar dónde se concentra la contratación de INVIAS.</a:t>
+            </a:r>
+            <a:endParaRPr dirty="0"/>
+          </a:p>
+        </p:txBody>
+      </p:sp>
+      <p:sp>
+        <p:nvSpPr>
+          <p:cNvPr id="9" name="Rounded Rectangle 8"/>
           <p:cNvSpPr/>
           <p:nvPr/>
         </p:nvSpPr>
         <p:spPr>
           <a:xfrm>
-            <a:off x="8101583" y="1298448"/>
-            <a:ext cx="3429000" cy="1024128"/>
+            <a:off x="7543800" y="3108960"/>
+            <a:ext cx="3931920" cy="1508760"/>
           </a:xfrm>
           <a:prstGeom prst="roundRect">
             <a:avLst/>
@@ -5117,14 +4692,14 @@
       </p:sp>
       <p:sp>
         <p:nvSpPr>
-          <p:cNvPr id="24" name="TextBox 23"/>
+          <p:cNvPr id="10" name="TextBox 9"/>
           <p:cNvSpPr txBox="1"/>
           <p:nvPr/>
         </p:nvSpPr>
         <p:spPr>
           <a:xfrm>
-            <a:off x="8238744" y="1417319"/>
-            <a:ext cx="3154680" cy="795528"/>
+            <a:off x="7726679" y="3255264"/>
+            <a:ext cx="3566160" cy="1092607"/>
           </a:xfrm>
           <a:prstGeom prst="rect">
             <a:avLst/>
@@ -5132,198 +4707,56 @@
           <a:noFill/>
         </p:spPr>
         <p:txBody>
-          <a:bodyPr wrap="none">
+          <a:bodyPr wrap="square">
             <a:spAutoFit/>
           </a:bodyPr>
           <a:lstStyle/>
           <a:p>
-            <a:pPr algn="ctr">
-              <a:defRPr sz="2400" b="1">
-                <a:solidFill>
-                  <a:srgbClr val="2D8264"/>
-                </a:solidFill>
-              </a:defRPr>
-            </a:pPr>
-            <a:r>
-              <a:t>750</a:t>
-            </a:r>
-          </a:p>
-          <a:p>
-            <a:pPr algn="ctr">
-              <a:defRPr sz="1000">
-                <a:solidFill>
-                  <a:srgbClr val="232B32"/>
-                </a:solidFill>
-              </a:defRPr>
-            </a:pPr>
-            <a:r>
-              <a:t>contratos prioritarios</a:t>
-            </a:r>
-          </a:p>
-        </p:txBody>
-      </p:sp>
-      <p:sp>
-        <p:nvSpPr>
-          <p:cNvPr id="25" name="Rounded Rectangle 24"/>
-          <p:cNvSpPr/>
-          <p:nvPr/>
-        </p:nvSpPr>
-        <p:spPr>
-          <a:xfrm>
-            <a:off x="640080" y="2542032"/>
-            <a:ext cx="6720840" cy="2697480"/>
-          </a:xfrm>
-          <a:prstGeom prst="roundRect">
-            <a:avLst/>
-          </a:prstGeom>
-          <a:solidFill>
-            <a:srgbClr val="FFFFFF"/>
-          </a:solidFill>
-          <a:ln>
-            <a:solidFill>
-              <a:srgbClr val="E1E6EB"/>
-            </a:solidFill>
-          </a:ln>
-        </p:spPr>
-        <p:style>
-          <a:lnRef idx="1">
-            <a:schemeClr val="accent1"/>
-          </a:lnRef>
-          <a:fillRef idx="3">
-            <a:schemeClr val="accent1"/>
-          </a:fillRef>
-          <a:effectRef idx="2">
-            <a:schemeClr val="accent1"/>
-          </a:effectRef>
-          <a:fontRef idx="minor">
-            <a:schemeClr val="lt1"/>
-          </a:fontRef>
-        </p:style>
-        <p:txBody>
-          <a:bodyPr rtlCol="0" anchor="ctr"/>
-          <a:lstStyle/>
-          <a:p>
-            <a:pPr algn="ctr"/>
-            <a:endParaRPr/>
-          </a:p>
-        </p:txBody>
-      </p:sp>
-      <p:sp>
-        <p:nvSpPr>
-          <p:cNvPr id="26" name="TextBox 25"/>
-          <p:cNvSpPr txBox="1"/>
-          <p:nvPr/>
-        </p:nvSpPr>
-        <p:spPr>
-          <a:xfrm>
-            <a:off x="914400" y="2651759"/>
-            <a:ext cx="6172200" cy="320040"/>
-          </a:xfrm>
-          <a:prstGeom prst="rect">
-            <a:avLst/>
-          </a:prstGeom>
-          <a:noFill/>
-        </p:spPr>
-        <p:txBody>
-          <a:bodyPr wrap="none">
-            <a:spAutoFit/>
-          </a:bodyPr>
-          <a:lstStyle/>
-          <a:p>
             <a:pPr>
               <a:defRPr sz="1200" b="1">
                 <a:solidFill>
-                  <a:srgbClr val="123052"/>
+                  <a:srgbClr val="2366AA"/>
                 </a:solidFill>
               </a:defRPr>
             </a:pPr>
             <a:r>
               <a:rPr dirty="0"/>
-              <a:t>VISUALIZACIÓN PRINCIPAL</a:t>
-            </a:r>
-          </a:p>
-        </p:txBody>
-      </p:sp>
-      <p:sp>
-        <p:nvSpPr>
-          <p:cNvPr id="27" name="TextBox 26"/>
-          <p:cNvSpPr txBox="1"/>
-          <p:nvPr/>
-        </p:nvSpPr>
-        <p:spPr>
-          <a:xfrm>
-            <a:off x="1051560" y="3703320"/>
-            <a:ext cx="5897880" cy="685800"/>
-          </a:xfrm>
-          <a:prstGeom prst="rect">
-            <a:avLst/>
-          </a:prstGeom>
-          <a:noFill/>
-        </p:spPr>
-        <p:txBody>
-          <a:bodyPr wrap="none">
-            <a:spAutoFit/>
-          </a:bodyPr>
-          <a:lstStyle/>
-          <a:p>
-            <a:pPr algn="ctr">
-              <a:defRPr sz="2000" b="1">
-                <a:solidFill>
-                  <a:srgbClr val="647382"/>
+              <a:t>HALLAZGO 02</a:t>
+            </a:r>
+          </a:p>
+          <a:p>
+            <a:pPr algn="just">
+              <a:spcBef>
+                <a:spcPts val="600"/>
+              </a:spcBef>
+              <a:defRPr sz="1200">
+                <a:solidFill>
+                  <a:srgbClr val="232B32"/>
                 </a:solidFill>
               </a:defRPr>
             </a:pPr>
             <a:r>
-              <a:t>INSERTAR PANTALLAZO / GRÁFICO</a:t>
-            </a:r>
-          </a:p>
-        </p:txBody>
-      </p:sp>
-      <p:sp>
-        <p:nvSpPr>
-          <p:cNvPr id="28" name="TextBox 27"/>
-          <p:cNvSpPr txBox="1"/>
-          <p:nvPr/>
-        </p:nvSpPr>
-        <p:spPr>
-          <a:xfrm>
-            <a:off x="1051560" y="4370832"/>
-            <a:ext cx="5897880" cy="411480"/>
-          </a:xfrm>
-          <a:prstGeom prst="rect">
-            <a:avLst/>
-          </a:prstGeom>
-          <a:noFill/>
-        </p:spPr>
-        <p:txBody>
-          <a:bodyPr wrap="none">
-            <a:spAutoFit/>
-          </a:bodyPr>
-          <a:lstStyle/>
-          <a:p>
-            <a:pPr algn="ctr">
-              <a:defRPr sz="1000">
-                <a:solidFill>
-                  <a:srgbClr val="647382"/>
-                </a:solidFill>
-              </a:defRPr>
-            </a:pPr>
-            <a:r>
-              <a:t>Sugerido: distribución por nivel de ejecución</a:t>
-            </a:r>
-          </a:p>
-        </p:txBody>
-      </p:sp>
-      <p:sp>
-        <p:nvSpPr>
-          <p:cNvPr id="29" name="Rounded Rectangle 28"/>
+              <a:rPr lang="es-CO" sz="1200" dirty="0">
+                <a:solidFill>
+                  <a:srgbClr val="232B32"/>
+                </a:solidFill>
+              </a:rPr>
+              <a:t>La trazabilidad es desigual: 40,9% de los contratos se asocia a un único departamento, 2,3% involucra varios departamentos y 56,7% no permite una asignación territorial confiable.</a:t>
+            </a:r>
+            <a:endParaRPr dirty="0"/>
+          </a:p>
+        </p:txBody>
+      </p:sp>
+      <p:sp>
+        <p:nvSpPr>
+          <p:cNvPr id="11" name="Rounded Rectangle 10"/>
           <p:cNvSpPr/>
           <p:nvPr/>
         </p:nvSpPr>
         <p:spPr>
           <a:xfrm>
-            <a:off x="7589520" y="2542032"/>
-            <a:ext cx="3941063" cy="1207008"/>
+            <a:off x="7543800" y="4800599"/>
+            <a:ext cx="3931920" cy="1238911"/>
           </a:xfrm>
           <a:prstGeom prst="roundRect">
             <a:avLst/>
@@ -5362,14 +4795,14 @@
       </p:sp>
       <p:sp>
         <p:nvSpPr>
-          <p:cNvPr id="30" name="TextBox 29"/>
+          <p:cNvPr id="12" name="TextBox 11"/>
           <p:cNvSpPr txBox="1"/>
           <p:nvPr/>
         </p:nvSpPr>
         <p:spPr>
           <a:xfrm>
-            <a:off x="7754112" y="2688336"/>
-            <a:ext cx="3611879" cy="932688"/>
+            <a:off x="7726679" y="4946904"/>
+            <a:ext cx="3566160" cy="1092607"/>
           </a:xfrm>
           <a:prstGeom prst="rect">
             <a:avLst/>
@@ -5383,139 +4816,50 @@
           <a:lstStyle/>
           <a:p>
             <a:pPr>
-              <a:defRPr sz="1100" b="1">
-                <a:solidFill>
-                  <a:srgbClr val="2366AA"/>
+              <a:defRPr sz="1200" b="1">
+                <a:solidFill>
+                  <a:srgbClr val="DC872D"/>
                 </a:solidFill>
               </a:defRPr>
             </a:pPr>
             <a:r>
-              <a:t>REGLA DE PRIORIZACIÓN</a:t>
-            </a:r>
-          </a:p>
-          <a:p>
-            <a:pPr>
+              <a:rPr dirty="0"/>
+              <a:t>IMPLICACIÓN</a:t>
+            </a:r>
+          </a:p>
+          <a:p>
+            <a:pPr algn="just">
               <a:spcBef>
-                <a:spcPts val="500"/>
+                <a:spcPts val="600"/>
               </a:spcBef>
-              <a:defRPr sz="1100">
+              <a:defRPr sz="1200">
                 <a:solidFill>
                   <a:srgbClr val="232B32"/>
                 </a:solidFill>
               </a:defRPr>
             </a:pPr>
             <a:r>
-              <a:t>P90 de recursos pendientes de ejecución + P90 de días adicionados.</a:t>
-            </a:r>
-          </a:p>
-        </p:txBody>
-      </p:sp>
-      <p:sp>
-        <p:nvSpPr>
-          <p:cNvPr id="31" name="Rounded Rectangle 30"/>
-          <p:cNvSpPr/>
-          <p:nvPr/>
-        </p:nvSpPr>
-        <p:spPr>
-          <a:xfrm>
-            <a:off x="7589520" y="3913632"/>
-            <a:ext cx="3941063" cy="1325880"/>
-          </a:xfrm>
-          <a:prstGeom prst="roundRect">
-            <a:avLst/>
-          </a:prstGeom>
-          <a:solidFill>
-            <a:srgbClr val="F2F5F8"/>
-          </a:solidFill>
-          <a:ln>
-            <a:solidFill>
-              <a:srgbClr val="E1E6EB"/>
-            </a:solidFill>
-          </a:ln>
-        </p:spPr>
-        <p:style>
-          <a:lnRef idx="1">
-            <a:schemeClr val="accent1"/>
-          </a:lnRef>
-          <a:fillRef idx="3">
-            <a:schemeClr val="accent1"/>
-          </a:fillRef>
-          <a:effectRef idx="2">
-            <a:schemeClr val="accent1"/>
-          </a:effectRef>
-          <a:fontRef idx="minor">
-            <a:schemeClr val="lt1"/>
-          </a:fontRef>
-        </p:style>
-        <p:txBody>
-          <a:bodyPr rtlCol="0" anchor="ctr"/>
-          <a:lstStyle/>
-          <a:p>
-            <a:pPr algn="ctr"/>
-            <a:endParaRPr/>
-          </a:p>
-        </p:txBody>
-      </p:sp>
-      <p:sp>
-        <p:nvSpPr>
-          <p:cNvPr id="32" name="TextBox 31"/>
+              <a:rPr lang="es-CO" sz="1200" dirty="0">
+                <a:solidFill>
+                  <a:srgbClr val="232B32"/>
+                </a:solidFill>
+              </a:rPr>
+              <a:t>La información permite priorizar el análisis territorial sobre la mayor parte de los recursos, pero la ubicación debe interpretarse como una señal de referencia y no necesariamente como evidencia de ejecución física.</a:t>
+            </a:r>
+            <a:endParaRPr dirty="0"/>
+          </a:p>
+        </p:txBody>
+      </p:sp>
+      <p:sp>
+        <p:nvSpPr>
+          <p:cNvPr id="13" name="TextBox 12"/>
           <p:cNvSpPr txBox="1"/>
           <p:nvPr/>
         </p:nvSpPr>
         <p:spPr>
           <a:xfrm>
-            <a:off x="7754112" y="4059936"/>
-            <a:ext cx="3611879" cy="1051560"/>
-          </a:xfrm>
-          <a:prstGeom prst="rect">
-            <a:avLst/>
-          </a:prstGeom>
-          <a:noFill/>
-        </p:spPr>
-        <p:txBody>
-          <a:bodyPr wrap="square">
-            <a:spAutoFit/>
-          </a:bodyPr>
-          <a:lstStyle/>
-          <a:p>
-            <a:pPr>
-              <a:defRPr sz="1100" b="1">
-                <a:solidFill>
-                  <a:srgbClr val="DC872D"/>
-                </a:solidFill>
-              </a:defRPr>
-            </a:pPr>
-            <a:r>
-              <a:t>SEÑAL CLAVE</a:t>
-            </a:r>
-          </a:p>
-          <a:p>
-            <a:pPr>
-              <a:spcBef>
-                <a:spcPts val="500"/>
-              </a:spcBef>
-              <a:defRPr sz="1100">
-                <a:solidFill>
-                  <a:srgbClr val="232B32"/>
-                </a:solidFill>
-              </a:defRPr>
-            </a:pPr>
-            <a:r>
-              <a:t>100 % de los contratos prioritarios presenta extensión contractual.</a:t>
-            </a:r>
-          </a:p>
-        </p:txBody>
-      </p:sp>
-      <p:sp>
-        <p:nvSpPr>
-          <p:cNvPr id="33" name="TextBox 32"/>
-          <p:cNvSpPr txBox="1"/>
-          <p:nvPr/>
-        </p:nvSpPr>
-        <p:spPr>
-          <a:xfrm>
-            <a:off x="822960" y="5532120"/>
-            <a:ext cx="10607040" cy="566928"/>
+            <a:off x="594360" y="6492240"/>
+            <a:ext cx="10972800" cy="182880"/>
           </a:xfrm>
           <a:prstGeom prst="rect">
             <a:avLst/>
@@ -5528,41 +4872,6 @@
           </a:bodyPr>
           <a:lstStyle/>
           <a:p>
-            <a:pPr algn="ctr">
-              <a:defRPr sz="1700" b="1">
-                <a:solidFill>
-                  <a:srgbClr val="123052"/>
-                </a:solidFill>
-              </a:defRPr>
-            </a:pPr>
-            <a:r>
-              <a:t>INSIGHT: pasar de 20.718 contratos a un universo focalizado de 750 casos para seguimiento.</a:t>
-            </a:r>
-          </a:p>
-        </p:txBody>
-      </p:sp>
-      <p:sp>
-        <p:nvSpPr>
-          <p:cNvPr id="34" name="TextBox 33"/>
-          <p:cNvSpPr txBox="1"/>
-          <p:nvPr/>
-        </p:nvSpPr>
-        <p:spPr>
-          <a:xfrm>
-            <a:off x="594360" y="6492240"/>
-            <a:ext cx="10972800" cy="182880"/>
-          </a:xfrm>
-          <a:prstGeom prst="rect">
-            <a:avLst/>
-          </a:prstGeom>
-          <a:noFill/>
-        </p:spPr>
-        <p:txBody>
-          <a:bodyPr wrap="none">
-            <a:spAutoFit/>
-          </a:bodyPr>
-          <a:lstStyle/>
-          <a:p>
             <a:pPr>
               <a:defRPr sz="800">
                 <a:solidFill>
@@ -5578,10 +4887,10 @@
       </p:sp>
       <p:pic>
         <p:nvPicPr>
-          <p:cNvPr id="2" name="Imagen 1">
+          <p:cNvPr id="14" name="Imagen 13">
             <a:extLst>
               <a:ext uri="{FF2B5EF4-FFF2-40B4-BE49-F238E27FC236}">
-                <a16:creationId xmlns:a16="http://schemas.microsoft.com/office/drawing/2014/main" id="{E6441D66-A37D-A733-0D1F-6D27C683E3A3}"/>
+                <a16:creationId xmlns:a16="http://schemas.microsoft.com/office/drawing/2014/main" id="{219C6468-D23B-32F9-49F2-8CA61769BD6B}"/>
               </a:ext>
             </a:extLst>
           </p:cNvPr>
@@ -5598,8 +4907,8 @@
         </p:blipFill>
         <p:spPr>
           <a:xfrm>
-            <a:off x="1941467" y="3011184"/>
-            <a:ext cx="3980905" cy="2070071"/>
+            <a:off x="1382268" y="1874520"/>
+            <a:ext cx="4883336" cy="3589020"/>
           </a:xfrm>
           <a:prstGeom prst="rect">
             <a:avLst/>
@@ -5644,6 +4953,891 @@
 </p:sld>
 </file>
 
+<file path=ppt/slides/slide4.xml><?xml version="1.0" encoding="utf-8"?>
+<p:sld xmlns:a="http://schemas.openxmlformats.org/drawingml/2006/main" xmlns:r="http://schemas.openxmlformats.org/officeDocument/2006/relationships" xmlns:p="http://schemas.openxmlformats.org/presentationml/2006/main">
+  <p:cSld>
+    <p:spTree>
+      <p:nvGrpSpPr>
+        <p:cNvPr id="1" name=""/>
+        <p:cNvGrpSpPr/>
+        <p:nvPr/>
+      </p:nvGrpSpPr>
+      <p:grpSpPr>
+        <a:xfrm>
+          <a:off x="0" y="0"/>
+          <a:ext cx="0" cy="0"/>
+          <a:chOff x="0" y="0"/>
+          <a:chExt cx="0" cy="0"/>
+        </a:xfrm>
+      </p:grpSpPr>
+      <p:sp>
+        <p:nvSpPr>
+          <p:cNvPr id="16" name="TextBox 15"/>
+          <p:cNvSpPr txBox="1"/>
+          <p:nvPr/>
+        </p:nvSpPr>
+        <p:spPr>
+          <a:xfrm>
+            <a:off x="594360" y="6492240"/>
+            <a:ext cx="10972800" cy="182880"/>
+          </a:xfrm>
+          <a:prstGeom prst="rect">
+            <a:avLst/>
+          </a:prstGeom>
+          <a:noFill/>
+        </p:spPr>
+        <p:txBody>
+          <a:bodyPr wrap="none">
+            <a:spAutoFit/>
+          </a:bodyPr>
+          <a:lstStyle/>
+          <a:p>
+            <a:pPr>
+              <a:defRPr sz="800">
+                <a:solidFill>
+                  <a:srgbClr val="647382"/>
+                </a:solidFill>
+              </a:defRPr>
+            </a:pPr>
+            <a:r>
+              <a:t>Proyecto 1 | INVIAS | Universidad de los Andes</a:t>
+            </a:r>
+          </a:p>
+        </p:txBody>
+      </p:sp>
+      <p:sp>
+        <p:nvSpPr>
+          <p:cNvPr id="17" name="TextBox 16"/>
+          <p:cNvSpPr txBox="1"/>
+          <p:nvPr/>
+        </p:nvSpPr>
+        <p:spPr>
+          <a:xfrm>
+            <a:off x="594360" y="320040"/>
+            <a:ext cx="10972800" cy="594360"/>
+          </a:xfrm>
+          <a:prstGeom prst="rect">
+            <a:avLst/>
+          </a:prstGeom>
+          <a:noFill/>
+        </p:spPr>
+        <p:txBody>
+          <a:bodyPr wrap="none">
+            <a:spAutoFit/>
+          </a:bodyPr>
+          <a:lstStyle/>
+          <a:p>
+            <a:pPr>
+              <a:defRPr sz="2700" b="1">
+                <a:solidFill>
+                  <a:srgbClr val="123052"/>
+                </a:solidFill>
+                <a:latin typeface="Aptos Display"/>
+              </a:defRPr>
+            </a:pPr>
+            <a:r>
+              <a:t>03 | Ejecución financiera y modificaciones</a:t>
+            </a:r>
+          </a:p>
+        </p:txBody>
+      </p:sp>
+      <p:sp>
+        <p:nvSpPr>
+          <p:cNvPr id="18" name="TextBox 17"/>
+          <p:cNvSpPr txBox="1"/>
+          <p:nvPr/>
+        </p:nvSpPr>
+        <p:spPr>
+          <a:xfrm>
+            <a:off x="612648" y="914400"/>
+            <a:ext cx="10789920" cy="365760"/>
+          </a:xfrm>
+          <a:prstGeom prst="rect">
+            <a:avLst/>
+          </a:prstGeom>
+          <a:noFill/>
+        </p:spPr>
+        <p:txBody>
+          <a:bodyPr wrap="none">
+            <a:spAutoFit/>
+          </a:bodyPr>
+          <a:lstStyle/>
+          <a:p>
+            <a:pPr>
+              <a:defRPr sz="1200">
+                <a:solidFill>
+                  <a:srgbClr val="647382"/>
+                </a:solidFill>
+                <a:latin typeface="Aptos"/>
+              </a:defRPr>
+            </a:pPr>
+            <a:r>
+              <a:t>¿Dónde debemos focalizar el seguimiento?</a:t>
+            </a:r>
+          </a:p>
+        </p:txBody>
+      </p:sp>
+      <p:sp>
+        <p:nvSpPr>
+          <p:cNvPr id="19" name="Rounded Rectangle 18"/>
+          <p:cNvSpPr/>
+          <p:nvPr/>
+        </p:nvSpPr>
+        <p:spPr>
+          <a:xfrm>
+            <a:off x="640080" y="1298448"/>
+            <a:ext cx="3429000" cy="1024128"/>
+          </a:xfrm>
+          <a:prstGeom prst="roundRect">
+            <a:avLst/>
+          </a:prstGeom>
+          <a:solidFill>
+            <a:srgbClr val="F2F5F8"/>
+          </a:solidFill>
+          <a:ln>
+            <a:solidFill>
+              <a:srgbClr val="E1E6EB"/>
+            </a:solidFill>
+          </a:ln>
+        </p:spPr>
+        <p:style>
+          <a:lnRef idx="1">
+            <a:schemeClr val="accent1"/>
+          </a:lnRef>
+          <a:fillRef idx="3">
+            <a:schemeClr val="accent1"/>
+          </a:fillRef>
+          <a:effectRef idx="2">
+            <a:schemeClr val="accent1"/>
+          </a:effectRef>
+          <a:fontRef idx="minor">
+            <a:schemeClr val="lt1"/>
+          </a:fontRef>
+        </p:style>
+        <p:txBody>
+          <a:bodyPr rtlCol="0" anchor="ctr"/>
+          <a:lstStyle/>
+          <a:p>
+            <a:pPr algn="ctr"/>
+            <a:endParaRPr/>
+          </a:p>
+        </p:txBody>
+      </p:sp>
+      <p:sp>
+        <p:nvSpPr>
+          <p:cNvPr id="20" name="TextBox 19"/>
+          <p:cNvSpPr txBox="1"/>
+          <p:nvPr/>
+        </p:nvSpPr>
+        <p:spPr>
+          <a:xfrm>
+            <a:off x="777240" y="1417319"/>
+            <a:ext cx="3154680" cy="795528"/>
+          </a:xfrm>
+          <a:prstGeom prst="rect">
+            <a:avLst/>
+          </a:prstGeom>
+          <a:noFill/>
+        </p:spPr>
+        <p:txBody>
+          <a:bodyPr wrap="none">
+            <a:spAutoFit/>
+          </a:bodyPr>
+          <a:lstStyle/>
+          <a:p>
+            <a:pPr algn="ctr">
+              <a:defRPr sz="2400" b="1">
+                <a:solidFill>
+                  <a:srgbClr val="2366AA"/>
+                </a:solidFill>
+              </a:defRPr>
+            </a:pPr>
+            <a:r>
+              <a:t>20.718</a:t>
+            </a:r>
+          </a:p>
+          <a:p>
+            <a:pPr algn="ctr">
+              <a:defRPr sz="1000">
+                <a:solidFill>
+                  <a:srgbClr val="232B32"/>
+                </a:solidFill>
+              </a:defRPr>
+            </a:pPr>
+            <a:r>
+              <a:t>contratos analizados</a:t>
+            </a:r>
+          </a:p>
+        </p:txBody>
+      </p:sp>
+      <p:sp>
+        <p:nvSpPr>
+          <p:cNvPr id="21" name="Rounded Rectangle 20"/>
+          <p:cNvSpPr/>
+          <p:nvPr/>
+        </p:nvSpPr>
+        <p:spPr>
+          <a:xfrm>
+            <a:off x="4370832" y="1298448"/>
+            <a:ext cx="3429000" cy="1024128"/>
+          </a:xfrm>
+          <a:prstGeom prst="roundRect">
+            <a:avLst/>
+          </a:prstGeom>
+          <a:solidFill>
+            <a:srgbClr val="F2F5F8"/>
+          </a:solidFill>
+          <a:ln>
+            <a:solidFill>
+              <a:srgbClr val="E1E6EB"/>
+            </a:solidFill>
+          </a:ln>
+        </p:spPr>
+        <p:style>
+          <a:lnRef idx="1">
+            <a:schemeClr val="accent1"/>
+          </a:lnRef>
+          <a:fillRef idx="3">
+            <a:schemeClr val="accent1"/>
+          </a:fillRef>
+          <a:effectRef idx="2">
+            <a:schemeClr val="accent1"/>
+          </a:effectRef>
+          <a:fontRef idx="minor">
+            <a:schemeClr val="lt1"/>
+          </a:fontRef>
+        </p:style>
+        <p:txBody>
+          <a:bodyPr rtlCol="0" anchor="ctr"/>
+          <a:lstStyle/>
+          <a:p>
+            <a:pPr algn="ctr"/>
+            <a:endParaRPr/>
+          </a:p>
+        </p:txBody>
+      </p:sp>
+      <p:sp>
+        <p:nvSpPr>
+          <p:cNvPr id="22" name="TextBox 21"/>
+          <p:cNvSpPr txBox="1"/>
+          <p:nvPr/>
+        </p:nvSpPr>
+        <p:spPr>
+          <a:xfrm>
+            <a:off x="4507992" y="1417319"/>
+            <a:ext cx="3154680" cy="795528"/>
+          </a:xfrm>
+          <a:prstGeom prst="rect">
+            <a:avLst/>
+          </a:prstGeom>
+          <a:noFill/>
+        </p:spPr>
+        <p:txBody>
+          <a:bodyPr wrap="none">
+            <a:spAutoFit/>
+          </a:bodyPr>
+          <a:lstStyle/>
+          <a:p>
+            <a:pPr algn="ctr">
+              <a:defRPr sz="2400" b="1">
+                <a:solidFill>
+                  <a:srgbClr val="DC872D"/>
+                </a:solidFill>
+              </a:defRPr>
+            </a:pPr>
+            <a:r>
+              <a:t>54,6 %</a:t>
+            </a:r>
+          </a:p>
+          <a:p>
+            <a:pPr algn="ctr">
+              <a:defRPr sz="1000">
+                <a:solidFill>
+                  <a:srgbClr val="232B32"/>
+                </a:solidFill>
+              </a:defRPr>
+            </a:pPr>
+            <a:r>
+              <a:t>con 0 % de ejecución registrada</a:t>
+            </a:r>
+          </a:p>
+        </p:txBody>
+      </p:sp>
+      <p:sp>
+        <p:nvSpPr>
+          <p:cNvPr id="23" name="Rounded Rectangle 22"/>
+          <p:cNvSpPr/>
+          <p:nvPr/>
+        </p:nvSpPr>
+        <p:spPr>
+          <a:xfrm>
+            <a:off x="8101583" y="1298448"/>
+            <a:ext cx="3429000" cy="1024128"/>
+          </a:xfrm>
+          <a:prstGeom prst="roundRect">
+            <a:avLst/>
+          </a:prstGeom>
+          <a:solidFill>
+            <a:srgbClr val="F2F5F8"/>
+          </a:solidFill>
+          <a:ln>
+            <a:solidFill>
+              <a:srgbClr val="E1E6EB"/>
+            </a:solidFill>
+          </a:ln>
+        </p:spPr>
+        <p:style>
+          <a:lnRef idx="1">
+            <a:schemeClr val="accent1"/>
+          </a:lnRef>
+          <a:fillRef idx="3">
+            <a:schemeClr val="accent1"/>
+          </a:fillRef>
+          <a:effectRef idx="2">
+            <a:schemeClr val="accent1"/>
+          </a:effectRef>
+          <a:fontRef idx="minor">
+            <a:schemeClr val="lt1"/>
+          </a:fontRef>
+        </p:style>
+        <p:txBody>
+          <a:bodyPr rtlCol="0" anchor="ctr"/>
+          <a:lstStyle/>
+          <a:p>
+            <a:pPr algn="ctr"/>
+            <a:endParaRPr/>
+          </a:p>
+        </p:txBody>
+      </p:sp>
+      <p:sp>
+        <p:nvSpPr>
+          <p:cNvPr id="24" name="TextBox 23"/>
+          <p:cNvSpPr txBox="1"/>
+          <p:nvPr/>
+        </p:nvSpPr>
+        <p:spPr>
+          <a:xfrm>
+            <a:off x="8238744" y="1417319"/>
+            <a:ext cx="3154680" cy="795528"/>
+          </a:xfrm>
+          <a:prstGeom prst="rect">
+            <a:avLst/>
+          </a:prstGeom>
+          <a:noFill/>
+        </p:spPr>
+        <p:txBody>
+          <a:bodyPr wrap="none">
+            <a:spAutoFit/>
+          </a:bodyPr>
+          <a:lstStyle/>
+          <a:p>
+            <a:pPr algn="ctr">
+              <a:defRPr sz="2400" b="1">
+                <a:solidFill>
+                  <a:srgbClr val="2D8264"/>
+                </a:solidFill>
+              </a:defRPr>
+            </a:pPr>
+            <a:r>
+              <a:t>750</a:t>
+            </a:r>
+          </a:p>
+          <a:p>
+            <a:pPr algn="ctr">
+              <a:defRPr sz="1000">
+                <a:solidFill>
+                  <a:srgbClr val="232B32"/>
+                </a:solidFill>
+              </a:defRPr>
+            </a:pPr>
+            <a:r>
+              <a:t>contratos prioritarios</a:t>
+            </a:r>
+          </a:p>
+        </p:txBody>
+      </p:sp>
+      <p:sp>
+        <p:nvSpPr>
+          <p:cNvPr id="25" name="Rounded Rectangle 24"/>
+          <p:cNvSpPr/>
+          <p:nvPr/>
+        </p:nvSpPr>
+        <p:spPr>
+          <a:xfrm>
+            <a:off x="640080" y="2542032"/>
+            <a:ext cx="6720840" cy="2697480"/>
+          </a:xfrm>
+          <a:prstGeom prst="roundRect">
+            <a:avLst/>
+          </a:prstGeom>
+          <a:solidFill>
+            <a:srgbClr val="FFFFFF"/>
+          </a:solidFill>
+          <a:ln>
+            <a:solidFill>
+              <a:srgbClr val="E1E6EB"/>
+            </a:solidFill>
+          </a:ln>
+        </p:spPr>
+        <p:style>
+          <a:lnRef idx="1">
+            <a:schemeClr val="accent1"/>
+          </a:lnRef>
+          <a:fillRef idx="3">
+            <a:schemeClr val="accent1"/>
+          </a:fillRef>
+          <a:effectRef idx="2">
+            <a:schemeClr val="accent1"/>
+          </a:effectRef>
+          <a:fontRef idx="minor">
+            <a:schemeClr val="lt1"/>
+          </a:fontRef>
+        </p:style>
+        <p:txBody>
+          <a:bodyPr rtlCol="0" anchor="ctr"/>
+          <a:lstStyle/>
+          <a:p>
+            <a:pPr algn="ctr"/>
+            <a:endParaRPr/>
+          </a:p>
+        </p:txBody>
+      </p:sp>
+      <p:sp>
+        <p:nvSpPr>
+          <p:cNvPr id="26" name="TextBox 25"/>
+          <p:cNvSpPr txBox="1"/>
+          <p:nvPr/>
+        </p:nvSpPr>
+        <p:spPr>
+          <a:xfrm>
+            <a:off x="914400" y="2651759"/>
+            <a:ext cx="6172200" cy="320040"/>
+          </a:xfrm>
+          <a:prstGeom prst="rect">
+            <a:avLst/>
+          </a:prstGeom>
+          <a:noFill/>
+        </p:spPr>
+        <p:txBody>
+          <a:bodyPr wrap="none">
+            <a:spAutoFit/>
+          </a:bodyPr>
+          <a:lstStyle/>
+          <a:p>
+            <a:pPr>
+              <a:defRPr sz="1200" b="1">
+                <a:solidFill>
+                  <a:srgbClr val="123052"/>
+                </a:solidFill>
+              </a:defRPr>
+            </a:pPr>
+            <a:r>
+              <a:rPr dirty="0"/>
+              <a:t>VISUALIZACIÓN PRINCIPAL</a:t>
+            </a:r>
+          </a:p>
+        </p:txBody>
+      </p:sp>
+      <p:sp>
+        <p:nvSpPr>
+          <p:cNvPr id="27" name="TextBox 26"/>
+          <p:cNvSpPr txBox="1"/>
+          <p:nvPr/>
+        </p:nvSpPr>
+        <p:spPr>
+          <a:xfrm>
+            <a:off x="1051560" y="3703320"/>
+            <a:ext cx="5897880" cy="685800"/>
+          </a:xfrm>
+          <a:prstGeom prst="rect">
+            <a:avLst/>
+          </a:prstGeom>
+          <a:noFill/>
+        </p:spPr>
+        <p:txBody>
+          <a:bodyPr wrap="none">
+            <a:spAutoFit/>
+          </a:bodyPr>
+          <a:lstStyle/>
+          <a:p>
+            <a:pPr algn="ctr">
+              <a:defRPr sz="2000" b="1">
+                <a:solidFill>
+                  <a:srgbClr val="647382"/>
+                </a:solidFill>
+              </a:defRPr>
+            </a:pPr>
+            <a:r>
+              <a:t>INSERTAR PANTALLAZO / GRÁFICO</a:t>
+            </a:r>
+          </a:p>
+        </p:txBody>
+      </p:sp>
+      <p:sp>
+        <p:nvSpPr>
+          <p:cNvPr id="28" name="TextBox 27"/>
+          <p:cNvSpPr txBox="1"/>
+          <p:nvPr/>
+        </p:nvSpPr>
+        <p:spPr>
+          <a:xfrm>
+            <a:off x="1051560" y="4370832"/>
+            <a:ext cx="5897880" cy="411480"/>
+          </a:xfrm>
+          <a:prstGeom prst="rect">
+            <a:avLst/>
+          </a:prstGeom>
+          <a:noFill/>
+        </p:spPr>
+        <p:txBody>
+          <a:bodyPr wrap="none">
+            <a:spAutoFit/>
+          </a:bodyPr>
+          <a:lstStyle/>
+          <a:p>
+            <a:pPr algn="ctr">
+              <a:defRPr sz="1000">
+                <a:solidFill>
+                  <a:srgbClr val="647382"/>
+                </a:solidFill>
+              </a:defRPr>
+            </a:pPr>
+            <a:r>
+              <a:t>Sugerido: distribución por nivel de ejecución</a:t>
+            </a:r>
+          </a:p>
+        </p:txBody>
+      </p:sp>
+      <p:sp>
+        <p:nvSpPr>
+          <p:cNvPr id="29" name="Rounded Rectangle 28"/>
+          <p:cNvSpPr/>
+          <p:nvPr/>
+        </p:nvSpPr>
+        <p:spPr>
+          <a:xfrm>
+            <a:off x="7589520" y="2542032"/>
+            <a:ext cx="3941063" cy="1207008"/>
+          </a:xfrm>
+          <a:prstGeom prst="roundRect">
+            <a:avLst/>
+          </a:prstGeom>
+          <a:solidFill>
+            <a:srgbClr val="F2F5F8"/>
+          </a:solidFill>
+          <a:ln>
+            <a:solidFill>
+              <a:srgbClr val="E1E6EB"/>
+            </a:solidFill>
+          </a:ln>
+        </p:spPr>
+        <p:style>
+          <a:lnRef idx="1">
+            <a:schemeClr val="accent1"/>
+          </a:lnRef>
+          <a:fillRef idx="3">
+            <a:schemeClr val="accent1"/>
+          </a:fillRef>
+          <a:effectRef idx="2">
+            <a:schemeClr val="accent1"/>
+          </a:effectRef>
+          <a:fontRef idx="minor">
+            <a:schemeClr val="lt1"/>
+          </a:fontRef>
+        </p:style>
+        <p:txBody>
+          <a:bodyPr rtlCol="0" anchor="ctr"/>
+          <a:lstStyle/>
+          <a:p>
+            <a:pPr algn="ctr"/>
+            <a:endParaRPr/>
+          </a:p>
+        </p:txBody>
+      </p:sp>
+      <p:sp>
+        <p:nvSpPr>
+          <p:cNvPr id="30" name="TextBox 29"/>
+          <p:cNvSpPr txBox="1"/>
+          <p:nvPr/>
+        </p:nvSpPr>
+        <p:spPr>
+          <a:xfrm>
+            <a:off x="7754112" y="2688336"/>
+            <a:ext cx="3611879" cy="932688"/>
+          </a:xfrm>
+          <a:prstGeom prst="rect">
+            <a:avLst/>
+          </a:prstGeom>
+          <a:noFill/>
+        </p:spPr>
+        <p:txBody>
+          <a:bodyPr wrap="square">
+            <a:spAutoFit/>
+          </a:bodyPr>
+          <a:lstStyle/>
+          <a:p>
+            <a:pPr>
+              <a:defRPr sz="1100" b="1">
+                <a:solidFill>
+                  <a:srgbClr val="2366AA"/>
+                </a:solidFill>
+              </a:defRPr>
+            </a:pPr>
+            <a:r>
+              <a:t>REGLA DE PRIORIZACIÓN</a:t>
+            </a:r>
+          </a:p>
+          <a:p>
+            <a:pPr>
+              <a:spcBef>
+                <a:spcPts val="500"/>
+              </a:spcBef>
+              <a:defRPr sz="1100">
+                <a:solidFill>
+                  <a:srgbClr val="232B32"/>
+                </a:solidFill>
+              </a:defRPr>
+            </a:pPr>
+            <a:r>
+              <a:t>P90 de recursos pendientes de ejecución + P90 de días adicionados.</a:t>
+            </a:r>
+          </a:p>
+        </p:txBody>
+      </p:sp>
+      <p:sp>
+        <p:nvSpPr>
+          <p:cNvPr id="31" name="Rounded Rectangle 30"/>
+          <p:cNvSpPr/>
+          <p:nvPr/>
+        </p:nvSpPr>
+        <p:spPr>
+          <a:xfrm>
+            <a:off x="7589520" y="3913632"/>
+            <a:ext cx="3941063" cy="1325880"/>
+          </a:xfrm>
+          <a:prstGeom prst="roundRect">
+            <a:avLst/>
+          </a:prstGeom>
+          <a:solidFill>
+            <a:srgbClr val="F2F5F8"/>
+          </a:solidFill>
+          <a:ln>
+            <a:solidFill>
+              <a:srgbClr val="E1E6EB"/>
+            </a:solidFill>
+          </a:ln>
+        </p:spPr>
+        <p:style>
+          <a:lnRef idx="1">
+            <a:schemeClr val="accent1"/>
+          </a:lnRef>
+          <a:fillRef idx="3">
+            <a:schemeClr val="accent1"/>
+          </a:fillRef>
+          <a:effectRef idx="2">
+            <a:schemeClr val="accent1"/>
+          </a:effectRef>
+          <a:fontRef idx="minor">
+            <a:schemeClr val="lt1"/>
+          </a:fontRef>
+        </p:style>
+        <p:txBody>
+          <a:bodyPr rtlCol="0" anchor="ctr"/>
+          <a:lstStyle/>
+          <a:p>
+            <a:pPr algn="ctr"/>
+            <a:endParaRPr/>
+          </a:p>
+        </p:txBody>
+      </p:sp>
+      <p:sp>
+        <p:nvSpPr>
+          <p:cNvPr id="32" name="TextBox 31"/>
+          <p:cNvSpPr txBox="1"/>
+          <p:nvPr/>
+        </p:nvSpPr>
+        <p:spPr>
+          <a:xfrm>
+            <a:off x="7754112" y="4059936"/>
+            <a:ext cx="3611879" cy="1051560"/>
+          </a:xfrm>
+          <a:prstGeom prst="rect">
+            <a:avLst/>
+          </a:prstGeom>
+          <a:noFill/>
+        </p:spPr>
+        <p:txBody>
+          <a:bodyPr wrap="square">
+            <a:spAutoFit/>
+          </a:bodyPr>
+          <a:lstStyle/>
+          <a:p>
+            <a:pPr>
+              <a:defRPr sz="1100" b="1">
+                <a:solidFill>
+                  <a:srgbClr val="DC872D"/>
+                </a:solidFill>
+              </a:defRPr>
+            </a:pPr>
+            <a:r>
+              <a:t>SEÑAL CLAVE</a:t>
+            </a:r>
+          </a:p>
+          <a:p>
+            <a:pPr>
+              <a:spcBef>
+                <a:spcPts val="500"/>
+              </a:spcBef>
+              <a:defRPr sz="1100">
+                <a:solidFill>
+                  <a:srgbClr val="232B32"/>
+                </a:solidFill>
+              </a:defRPr>
+            </a:pPr>
+            <a:r>
+              <a:t>100 % de los contratos prioritarios presenta extensión contractual.</a:t>
+            </a:r>
+          </a:p>
+        </p:txBody>
+      </p:sp>
+      <p:sp>
+        <p:nvSpPr>
+          <p:cNvPr id="33" name="TextBox 32"/>
+          <p:cNvSpPr txBox="1"/>
+          <p:nvPr/>
+        </p:nvSpPr>
+        <p:spPr>
+          <a:xfrm>
+            <a:off x="822960" y="5532120"/>
+            <a:ext cx="10607040" cy="566928"/>
+          </a:xfrm>
+          <a:prstGeom prst="rect">
+            <a:avLst/>
+          </a:prstGeom>
+          <a:noFill/>
+        </p:spPr>
+        <p:txBody>
+          <a:bodyPr wrap="none">
+            <a:spAutoFit/>
+          </a:bodyPr>
+          <a:lstStyle/>
+          <a:p>
+            <a:pPr algn="ctr">
+              <a:defRPr sz="1700" b="1">
+                <a:solidFill>
+                  <a:srgbClr val="123052"/>
+                </a:solidFill>
+              </a:defRPr>
+            </a:pPr>
+            <a:r>
+              <a:t>INSIGHT: pasar de 20.718 contratos a un universo focalizado de 750 casos para seguimiento.</a:t>
+            </a:r>
+          </a:p>
+        </p:txBody>
+      </p:sp>
+      <p:sp>
+        <p:nvSpPr>
+          <p:cNvPr id="34" name="TextBox 33"/>
+          <p:cNvSpPr txBox="1"/>
+          <p:nvPr/>
+        </p:nvSpPr>
+        <p:spPr>
+          <a:xfrm>
+            <a:off x="594360" y="6492240"/>
+            <a:ext cx="10972800" cy="182880"/>
+          </a:xfrm>
+          <a:prstGeom prst="rect">
+            <a:avLst/>
+          </a:prstGeom>
+          <a:noFill/>
+        </p:spPr>
+        <p:txBody>
+          <a:bodyPr wrap="none">
+            <a:spAutoFit/>
+          </a:bodyPr>
+          <a:lstStyle/>
+          <a:p>
+            <a:pPr>
+              <a:defRPr sz="800">
+                <a:solidFill>
+                  <a:srgbClr val="647382"/>
+                </a:solidFill>
+              </a:defRPr>
+            </a:pPr>
+            <a:r>
+              <a:t>Proyecto 1 | INVIAS | Universidad de los Andes</a:t>
+            </a:r>
+          </a:p>
+        </p:txBody>
+      </p:sp>
+      <p:pic>
+        <p:nvPicPr>
+          <p:cNvPr id="2" name="Imagen 1">
+            <a:extLst>
+              <a:ext uri="{FF2B5EF4-FFF2-40B4-BE49-F238E27FC236}">
+                <a16:creationId xmlns:a16="http://schemas.microsoft.com/office/drawing/2014/main" id="{E6441D66-A37D-A733-0D1F-6D27C683E3A3}"/>
+              </a:ext>
+            </a:extLst>
+          </p:cNvPr>
+          <p:cNvPicPr>
+            <a:picLocks noChangeAspect="1"/>
+          </p:cNvPicPr>
+          <p:nvPr/>
+        </p:nvPicPr>
+        <p:blipFill>
+          <a:blip r:embed="rId2"/>
+          <a:stretch>
+            <a:fillRect/>
+          </a:stretch>
+        </p:blipFill>
+        <p:spPr>
+          <a:xfrm>
+            <a:off x="1941467" y="3011184"/>
+            <a:ext cx="3980905" cy="2070071"/>
+          </a:xfrm>
+          <a:prstGeom prst="rect">
+            <a:avLst/>
+          </a:prstGeom>
+          <a:solidFill>
+            <a:srgbClr val="FFFFFF">
+              <a:shade val="85000"/>
+            </a:srgbClr>
+          </a:solidFill>
+          <a:ln w="88900" cap="sq">
+            <a:solidFill>
+              <a:srgbClr val="FFFFFF"/>
+            </a:solidFill>
+            <a:miter lim="800000"/>
+          </a:ln>
+          <a:effectLst>
+            <a:outerShdw blurRad="55000" dist="18000" dir="5400000" algn="tl" rotWithShape="0">
+              <a:srgbClr val="000000">
+                <a:alpha val="40000"/>
+              </a:srgbClr>
+            </a:outerShdw>
+          </a:effectLst>
+          <a:scene3d>
+            <a:camera prst="orthographicFront"/>
+            <a:lightRig rig="twoPt" dir="t">
+              <a:rot lat="0" lon="0" rev="7200000"/>
+            </a:lightRig>
+          </a:scene3d>
+          <a:sp3d>
+            <a:bevelT w="25400" h="19050"/>
+            <a:contourClr>
+              <a:srgbClr val="FFFFFF"/>
+            </a:contourClr>
+          </a:sp3d>
+        </p:spPr>
+      </p:pic>
+    </p:spTree>
+  </p:cSld>
+  <p:clrMapOvr>
+    <a:masterClrMapping/>
+  </p:clrMapOvr>
+</p:sld>
+</file>
+
 <file path=ppt/slides/slide5.xml><?xml version="1.0" encoding="utf-8"?>
 <p:sld xmlns:a="http://schemas.openxmlformats.org/drawingml/2006/main" xmlns:r="http://schemas.openxmlformats.org/officeDocument/2006/relationships" xmlns:p="http://schemas.openxmlformats.org/presentationml/2006/main">
   <p:cSld>
@@ -6225,7 +6419,7 @@
         <p:spPr>
           <a:xfrm>
             <a:off x="9500616" y="2203704"/>
-            <a:ext cx="2057400" cy="1280160"/>
+            <a:ext cx="2057400" cy="538609"/>
           </a:xfrm>
           <a:prstGeom prst="rect">
             <a:avLst/>
@@ -6246,6 +6440,11 @@
               </a:defRPr>
             </a:pPr>
             <a:r>
+              <a:rPr lang="es-419" dirty="0"/>
+              <a:t>FOCOS PARA </a:t>
+            </a:r>
+            <a:r>
+              <a:rPr dirty="0"/>
               <a:t>SEGUIMIENTO</a:t>
             </a:r>
           </a:p>
@@ -6261,8 +6460,18 @@
               </a:defRPr>
             </a:pPr>
             <a:r>
-              <a:t>Información focalizada</a:t>
-            </a:r>
+              <a:rPr dirty="0" err="1"/>
+              <a:t>Información</a:t>
+            </a:r>
+            <a:r>
+              <a:rPr dirty="0"/>
+              <a:t> </a:t>
+            </a:r>
+            <a:r>
+              <a:rPr dirty="0" err="1"/>
+              <a:t>focalizada</a:t>
+            </a:r>
+            <a:endParaRPr dirty="0"/>
           </a:p>
         </p:txBody>
       </p:sp>

</xml_diff>

<commit_message>
Presentacion: integrar la actualizacion de Javier y corregir la portada
Incorpora la implicacion que agrego Javier en la diapositiva de concentracion. La portada declaraba 20.718 contratos, que es el universo de la Pregunta 3; la base del proyecto son 25.605.
</commit_message>
<xml_diff>
--- a/Entregables/Presentacion_Proyecto_1_INVIAS.pptx
+++ b/Entregables/Presentacion_Proyecto_1_INVIAS.pptx
@@ -469,7 +469,7 @@
           <a:p>
             <a:fld id="{5BCAD085-E8A6-8845-BD4E-CB4CCA059FC4}" type="datetimeFigureOut">
               <a:rPr lang="en-US" smtClean="0"/>
-              <a:t>9/14/26</a:t>
+              <a:t>9/14/2026</a:t>
             </a:fld>
             <a:endParaRPr lang="en-US"/>
           </a:p>
@@ -637,7 +637,7 @@
           <a:p>
             <a:fld id="{5BCAD085-E8A6-8845-BD4E-CB4CCA059FC4}" type="datetimeFigureOut">
               <a:rPr lang="en-US" smtClean="0"/>
-              <a:t>9/14/26</a:t>
+              <a:t>9/14/2026</a:t>
             </a:fld>
             <a:endParaRPr lang="en-US"/>
           </a:p>
@@ -815,7 +815,7 @@
           <a:p>
             <a:fld id="{5BCAD085-E8A6-8845-BD4E-CB4CCA059FC4}" type="datetimeFigureOut">
               <a:rPr lang="en-US" smtClean="0"/>
-              <a:t>9/14/26</a:t>
+              <a:t>9/14/2026</a:t>
             </a:fld>
             <a:endParaRPr lang="en-US"/>
           </a:p>
@@ -983,7 +983,7 @@
           <a:p>
             <a:fld id="{5BCAD085-E8A6-8845-BD4E-CB4CCA059FC4}" type="datetimeFigureOut">
               <a:rPr lang="en-US" smtClean="0"/>
-              <a:t>9/14/26</a:t>
+              <a:t>9/14/2026</a:t>
             </a:fld>
             <a:endParaRPr lang="en-US"/>
           </a:p>
@@ -1228,7 +1228,7 @@
           <a:p>
             <a:fld id="{5BCAD085-E8A6-8845-BD4E-CB4CCA059FC4}" type="datetimeFigureOut">
               <a:rPr lang="en-US" smtClean="0"/>
-              <a:t>9/14/26</a:t>
+              <a:t>9/14/2026</a:t>
             </a:fld>
             <a:endParaRPr lang="en-US"/>
           </a:p>
@@ -1513,7 +1513,7 @@
           <a:p>
             <a:fld id="{5BCAD085-E8A6-8845-BD4E-CB4CCA059FC4}" type="datetimeFigureOut">
               <a:rPr lang="en-US" smtClean="0"/>
-              <a:t>9/14/26</a:t>
+              <a:t>9/14/2026</a:t>
             </a:fld>
             <a:endParaRPr lang="en-US"/>
           </a:p>
@@ -1932,7 +1932,7 @@
           <a:p>
             <a:fld id="{5BCAD085-E8A6-8845-BD4E-CB4CCA059FC4}" type="datetimeFigureOut">
               <a:rPr lang="en-US" smtClean="0"/>
-              <a:t>9/14/26</a:t>
+              <a:t>9/14/2026</a:t>
             </a:fld>
             <a:endParaRPr lang="en-US"/>
           </a:p>
@@ -2049,7 +2049,7 @@
           <a:p>
             <a:fld id="{5BCAD085-E8A6-8845-BD4E-CB4CCA059FC4}" type="datetimeFigureOut">
               <a:rPr lang="en-US" smtClean="0"/>
-              <a:t>9/14/26</a:t>
+              <a:t>9/14/2026</a:t>
             </a:fld>
             <a:endParaRPr lang="en-US"/>
           </a:p>
@@ -2144,7 +2144,7 @@
           <a:p>
             <a:fld id="{5BCAD085-E8A6-8845-BD4E-CB4CCA059FC4}" type="datetimeFigureOut">
               <a:rPr lang="en-US" smtClean="0"/>
-              <a:t>9/14/26</a:t>
+              <a:t>9/14/2026</a:t>
             </a:fld>
             <a:endParaRPr lang="en-US"/>
           </a:p>
@@ -2419,7 +2419,7 @@
           <a:p>
             <a:fld id="{5BCAD085-E8A6-8845-BD4E-CB4CCA059FC4}" type="datetimeFigureOut">
               <a:rPr lang="en-US" smtClean="0"/>
-              <a:t>9/14/26</a:t>
+              <a:t>9/14/2026</a:t>
             </a:fld>
             <a:endParaRPr lang="en-US"/>
           </a:p>
@@ -2671,7 +2671,7 @@
           <a:p>
             <a:fld id="{5BCAD085-E8A6-8845-BD4E-CB4CCA059FC4}" type="datetimeFigureOut">
               <a:rPr lang="en-US" smtClean="0"/>
-              <a:t>9/14/26</a:t>
+              <a:t>9/14/2026</a:t>
             </a:fld>
             <a:endParaRPr lang="en-US"/>
           </a:p>
@@ -2882,7 +2882,7 @@
           <a:p>
             <a:fld id="{5BCAD085-E8A6-8845-BD4E-CB4CCA059FC4}" type="datetimeFigureOut">
               <a:rPr lang="en-US" smtClean="0"/>
-              <a:t>9/14/26</a:t>
+              <a:t>9/14/2026</a:t>
             </a:fld>
             <a:endParaRPr lang="en-US"/>
           </a:p>
@@ -3494,7 +3494,7 @@
         <p:spPr>
           <a:xfrm>
             <a:off x="914400" y="4306824"/>
-            <a:ext cx="3017520" cy="960120"/>
+            <a:ext cx="3017520" cy="907941"/>
           </a:xfrm>
           <a:prstGeom prst="rect">
             <a:avLst/>
@@ -3515,6 +3515,7 @@
               </a:defRPr>
             </a:pPr>
             <a:r>
+              <a:rPr sz="2400" dirty="0"/>
               <a:t>01</a:t>
             </a:r>
           </a:p>
@@ -3530,8 +3531,10 @@
               </a:defRPr>
             </a:pPr>
             <a:r>
+              <a:rPr sz="2400" dirty="0" err="1"/>
               <a:t>Concentración</a:t>
             </a:r>
+            <a:endParaRPr sz="2400" dirty="0"/>
           </a:p>
         </p:txBody>
       </p:sp>
@@ -3590,7 +3593,7 @@
         <p:spPr>
           <a:xfrm>
             <a:off x="4617720" y="4306824"/>
-            <a:ext cx="3017520" cy="960120"/>
+            <a:ext cx="3017520" cy="907941"/>
           </a:xfrm>
           <a:prstGeom prst="rect">
             <a:avLst/>
@@ -3611,6 +3614,7 @@
               </a:defRPr>
             </a:pPr>
             <a:r>
+              <a:rPr sz="2400" dirty="0"/>
               <a:t>02</a:t>
             </a:r>
           </a:p>
@@ -3626,8 +3630,10 @@
               </a:defRPr>
             </a:pPr>
             <a:r>
+              <a:rPr sz="2400" dirty="0" err="1"/>
               <a:t>Territorio</a:t>
             </a:r>
+            <a:endParaRPr sz="2400" dirty="0"/>
           </a:p>
         </p:txBody>
       </p:sp>
@@ -3686,7 +3692,7 @@
         <p:spPr>
           <a:xfrm>
             <a:off x="8321040" y="4306824"/>
-            <a:ext cx="3017520" cy="960120"/>
+            <a:ext cx="3017520" cy="907941"/>
           </a:xfrm>
           <a:prstGeom prst="rect">
             <a:avLst/>
@@ -3707,6 +3713,7 @@
               </a:defRPr>
             </a:pPr>
             <a:r>
+              <a:rPr sz="2400" dirty="0"/>
               <a:t>03</a:t>
             </a:r>
           </a:p>
@@ -3722,8 +3729,10 @@
               </a:defRPr>
             </a:pPr>
             <a:r>
+              <a:rPr sz="2400" dirty="0" err="1"/>
               <a:t>Ejecución</a:t>
             </a:r>
+            <a:endParaRPr sz="2400" dirty="0"/>
           </a:p>
         </p:txBody>
       </p:sp>
@@ -3911,8 +3920,8 @@
         </p:nvSpPr>
         <p:spPr>
           <a:xfrm>
-            <a:off x="640080" y="1508760"/>
-            <a:ext cx="3200400" cy="1828800"/>
+            <a:off x="640126" y="1313720"/>
+            <a:ext cx="3859847" cy="1487359"/>
           </a:xfrm>
           <a:prstGeom prst="roundRect">
             <a:avLst/>
@@ -3957,7 +3966,7 @@
         </p:nvSpPr>
         <p:spPr>
           <a:xfrm>
-            <a:off x="822959" y="1655063"/>
+            <a:off x="1150215" y="1460023"/>
             <a:ext cx="2834640" cy="1092607"/>
           </a:xfrm>
           <a:prstGeom prst="rect">
@@ -4008,14 +4017,14 @@
       </p:sp>
       <p:sp>
         <p:nvSpPr>
-          <p:cNvPr id="7" name="Rounded Rectangle 6"/>
+          <p:cNvPr id="9" name="Rounded Rectangle 8"/>
           <p:cNvSpPr/>
           <p:nvPr/>
         </p:nvSpPr>
         <p:spPr>
           <a:xfrm>
-            <a:off x="640080" y="3520440"/>
-            <a:ext cx="3200400" cy="1828800"/>
+            <a:off x="5010683" y="1312611"/>
+            <a:ext cx="6670256" cy="4759622"/>
           </a:xfrm>
           <a:prstGeom prst="roundRect">
             <a:avLst/>
@@ -4054,14 +4063,14 @@
       </p:sp>
       <p:sp>
         <p:nvSpPr>
-          <p:cNvPr id="8" name="TextBox 7"/>
+          <p:cNvPr id="10" name="TextBox 9"/>
           <p:cNvSpPr txBox="1"/>
           <p:nvPr/>
         </p:nvSpPr>
         <p:spPr>
           <a:xfrm>
-            <a:off x="822959" y="3666744"/>
-            <a:ext cx="2834640" cy="1461939"/>
+            <a:off x="7333161" y="1442377"/>
+            <a:ext cx="3036003" cy="307777"/>
           </a:xfrm>
           <a:prstGeom prst="rect">
             <a:avLst/>
@@ -4075,50 +4084,70 @@
           <a:lstStyle/>
           <a:p>
             <a:pPr>
-              <a:defRPr sz="1200" b="1">
-                <a:solidFill>
-                  <a:srgbClr val="2366AA"/>
+              <a:defRPr sz="1400" b="1">
+                <a:solidFill>
+                  <a:srgbClr val="123052"/>
                 </a:solidFill>
               </a:defRPr>
             </a:pPr>
             <a:r>
               <a:rPr dirty="0"/>
-              <a:t>HALLAZGO</a:t>
-            </a:r>
-          </a:p>
-          <a:p>
-            <a:pPr algn="just">
-              <a:spcBef>
-                <a:spcPts val="600"/>
-              </a:spcBef>
-              <a:defRPr sz="1200">
-                <a:solidFill>
-                  <a:srgbClr val="232B32"/>
+              <a:t>VISUALIZACIÓN PRINCIPAL</a:t>
+            </a:r>
+          </a:p>
+        </p:txBody>
+      </p:sp>
+      <p:sp>
+        <p:nvSpPr>
+          <p:cNvPr id="12" name="TextBox 11"/>
+          <p:cNvSpPr txBox="1"/>
+          <p:nvPr/>
+        </p:nvSpPr>
+        <p:spPr>
+          <a:xfrm>
+            <a:off x="594360" y="6492240"/>
+            <a:ext cx="10972800" cy="182880"/>
+          </a:xfrm>
+          <a:prstGeom prst="rect">
+            <a:avLst/>
+          </a:prstGeom>
+          <a:noFill/>
+        </p:spPr>
+        <p:txBody>
+          <a:bodyPr wrap="none">
+            <a:spAutoFit/>
+          </a:bodyPr>
+          <a:lstStyle/>
+          <a:p>
+            <a:pPr>
+              <a:defRPr sz="800">
+                <a:solidFill>
+                  <a:srgbClr val="647382"/>
                 </a:solidFill>
               </a:defRPr>
             </a:pPr>
             <a:r>
-              <a:rPr lang="es-CO" sz="1200" dirty="0">
-                <a:solidFill>
-                  <a:srgbClr val="232B32"/>
-                </a:solidFill>
-              </a:rPr>
-              <a:t>La concentración cambia significativamente según el tipo y modalidad contractual: los contratos de Obra representan el 15,4 % de los contratos, pero concentran el 66,3 % del valor contratado.</a:t>
-            </a:r>
-            <a:endParaRPr dirty="0"/>
-          </a:p>
-        </p:txBody>
-      </p:sp>
-      <p:sp>
-        <p:nvSpPr>
-          <p:cNvPr id="9" name="Rounded Rectangle 8"/>
+              <a:t>Proyecto 1 | INVIAS | Universidad de los Andes</a:t>
+            </a:r>
+          </a:p>
+        </p:txBody>
+      </p:sp>
+      <p:sp>
+        <p:nvSpPr>
+          <p:cNvPr id="16" name="Rounded Rectangle 4">
+            <a:extLst>
+              <a:ext uri="{FF2B5EF4-FFF2-40B4-BE49-F238E27FC236}">
+                <a16:creationId xmlns:a16="http://schemas.microsoft.com/office/drawing/2014/main" id="{7533928D-DFDA-ED1B-A253-903B5482894E}"/>
+              </a:ext>
+            </a:extLst>
+          </p:cNvPr>
           <p:cNvSpPr/>
           <p:nvPr/>
         </p:nvSpPr>
         <p:spPr>
           <a:xfrm>
-            <a:off x="4160520" y="1508760"/>
-            <a:ext cx="7315200" cy="3840480"/>
+            <a:off x="640080" y="2959640"/>
+            <a:ext cx="3859847" cy="1487359"/>
           </a:xfrm>
           <a:prstGeom prst="roundRect">
             <a:avLst/>
@@ -4155,82 +4184,12 @@
           </a:p>
         </p:txBody>
       </p:sp>
-      <p:sp>
-        <p:nvSpPr>
-          <p:cNvPr id="10" name="TextBox 9"/>
-          <p:cNvSpPr txBox="1"/>
-          <p:nvPr/>
-        </p:nvSpPr>
-        <p:spPr>
-          <a:xfrm>
-            <a:off x="4434840" y="1783080"/>
-            <a:ext cx="6766560" cy="365760"/>
-          </a:xfrm>
-          <a:prstGeom prst="rect">
-            <a:avLst/>
-          </a:prstGeom>
-          <a:noFill/>
-        </p:spPr>
-        <p:txBody>
-          <a:bodyPr wrap="none">
-            <a:spAutoFit/>
-          </a:bodyPr>
-          <a:lstStyle/>
-          <a:p>
-            <a:pPr>
-              <a:defRPr sz="1400" b="1">
-                <a:solidFill>
-                  <a:srgbClr val="123052"/>
-                </a:solidFill>
-              </a:defRPr>
-            </a:pPr>
-            <a:r>
-              <a:t>VISUALIZACIÓN PRINCIPAL</a:t>
-            </a:r>
-          </a:p>
-        </p:txBody>
-      </p:sp>
-      <p:sp>
-        <p:nvSpPr>
-          <p:cNvPr id="12" name="TextBox 11"/>
-          <p:cNvSpPr txBox="1"/>
-          <p:nvPr/>
-        </p:nvSpPr>
-        <p:spPr>
-          <a:xfrm>
-            <a:off x="594360" y="6492240"/>
-            <a:ext cx="10972800" cy="182880"/>
-          </a:xfrm>
-          <a:prstGeom prst="rect">
-            <a:avLst/>
-          </a:prstGeom>
-          <a:noFill/>
-        </p:spPr>
-        <p:txBody>
-          <a:bodyPr wrap="none">
-            <a:spAutoFit/>
-          </a:bodyPr>
-          <a:lstStyle/>
-          <a:p>
-            <a:pPr>
-              <a:defRPr sz="800">
-                <a:solidFill>
-                  <a:srgbClr val="647382"/>
-                </a:solidFill>
-              </a:defRPr>
-            </a:pPr>
-            <a:r>
-              <a:t>Proyecto 1 | INVIAS | Universidad de los Andes</a:t>
-            </a:r>
-          </a:p>
-        </p:txBody>
-      </p:sp>
       <p:pic>
         <p:nvPicPr>
-          <p:cNvPr id="13" name="Imagen 12">
+          <p:cNvPr id="14" name="Imagen 13">
             <a:extLst>
               <a:ext uri="{FF2B5EF4-FFF2-40B4-BE49-F238E27FC236}">
-                <a16:creationId xmlns:a16="http://schemas.microsoft.com/office/drawing/2014/main" id="{038A5DD4-2999-768C-C07A-AE60D3567394}"/>
+                <a16:creationId xmlns:a16="http://schemas.microsoft.com/office/drawing/2014/main" id="{85D3CD95-24B3-0FAB-DFE0-249904696567}"/>
               </a:ext>
             </a:extLst>
           </p:cNvPr>
@@ -4247,44 +4206,195 @@
         </p:blipFill>
         <p:spPr>
           <a:xfrm>
-            <a:off x="4895616" y="2129246"/>
-            <a:ext cx="6035817" cy="2952629"/>
+            <a:off x="5661212" y="1750153"/>
+            <a:ext cx="5380620" cy="3919127"/>
           </a:xfrm>
           <a:prstGeom prst="rect">
             <a:avLst/>
           </a:prstGeom>
+        </p:spPr>
+      </p:pic>
+      <p:sp>
+        <p:nvSpPr>
+          <p:cNvPr id="8" name="TextBox 7"/>
+          <p:cNvSpPr txBox="1"/>
+          <p:nvPr/>
+        </p:nvSpPr>
+        <p:spPr>
+          <a:xfrm>
+            <a:off x="1024332" y="3097515"/>
+            <a:ext cx="3328356" cy="1092607"/>
+          </a:xfrm>
+          <a:prstGeom prst="rect">
+            <a:avLst/>
+          </a:prstGeom>
+          <a:noFill/>
+        </p:spPr>
+        <p:txBody>
+          <a:bodyPr wrap="square">
+            <a:spAutoFit/>
+          </a:bodyPr>
+          <a:lstStyle/>
+          <a:p>
+            <a:pPr>
+              <a:defRPr sz="1200" b="1">
+                <a:solidFill>
+                  <a:srgbClr val="2366AA"/>
+                </a:solidFill>
+              </a:defRPr>
+            </a:pPr>
+            <a:r>
+              <a:rPr dirty="0"/>
+              <a:t>HALLAZGO</a:t>
+            </a:r>
+          </a:p>
+          <a:p>
+            <a:pPr algn="just">
+              <a:spcBef>
+                <a:spcPts val="600"/>
+              </a:spcBef>
+              <a:defRPr sz="1200">
+                <a:solidFill>
+                  <a:srgbClr val="232B32"/>
+                </a:solidFill>
+              </a:defRPr>
+            </a:pPr>
+            <a:r>
+              <a:rPr lang="es-CO" sz="1200" dirty="0">
+                <a:solidFill>
+                  <a:srgbClr val="232B32"/>
+                </a:solidFill>
+              </a:rPr>
+              <a:t>La concentración cambia significativamente según el tipo y modalidad contractual: los contratos de Obra representan el 15,4 % de los contratos, pero concentran el 66,3 % del valor contratado.</a:t>
+            </a:r>
+            <a:endParaRPr dirty="0"/>
+          </a:p>
+        </p:txBody>
+      </p:sp>
+      <p:sp>
+        <p:nvSpPr>
+          <p:cNvPr id="18" name="Rounded Rectangle 4">
+            <a:extLst>
+              <a:ext uri="{FF2B5EF4-FFF2-40B4-BE49-F238E27FC236}">
+                <a16:creationId xmlns:a16="http://schemas.microsoft.com/office/drawing/2014/main" id="{DAD2FEFA-25EE-00FA-DA6B-4191A428E8AB}"/>
+              </a:ext>
+            </a:extLst>
+          </p:cNvPr>
+          <p:cNvSpPr/>
+          <p:nvPr/>
+        </p:nvSpPr>
+        <p:spPr>
+          <a:xfrm>
+            <a:off x="612648" y="4584874"/>
+            <a:ext cx="3859847" cy="1487359"/>
+          </a:xfrm>
+          <a:prstGeom prst="roundRect">
+            <a:avLst/>
+          </a:prstGeom>
           <a:solidFill>
-            <a:srgbClr val="FFFFFF">
-              <a:shade val="85000"/>
-            </a:srgbClr>
+            <a:srgbClr val="F2F5F8"/>
           </a:solidFill>
-          <a:ln w="88900" cap="sq">
+          <a:ln>
             <a:solidFill>
-              <a:srgbClr val="FFFFFF"/>
+              <a:srgbClr val="E1E6EB"/>
             </a:solidFill>
-            <a:miter lim="800000"/>
           </a:ln>
-          <a:effectLst>
-            <a:outerShdw blurRad="55000" dist="18000" dir="5400000" algn="tl" rotWithShape="0">
-              <a:srgbClr val="000000">
-                <a:alpha val="40000"/>
-              </a:srgbClr>
-            </a:outerShdw>
-          </a:effectLst>
-          <a:scene3d>
-            <a:camera prst="orthographicFront"/>
-            <a:lightRig rig="twoPt" dir="t">
-              <a:rot lat="0" lon="0" rev="7200000"/>
-            </a:lightRig>
-          </a:scene3d>
-          <a:sp3d>
-            <a:bevelT w="25400" h="19050"/>
-            <a:contourClr>
-              <a:srgbClr val="FFFFFF"/>
-            </a:contourClr>
-          </a:sp3d>
-        </p:spPr>
-      </p:pic>
+        </p:spPr>
+        <p:style>
+          <a:lnRef idx="1">
+            <a:schemeClr val="accent1"/>
+          </a:lnRef>
+          <a:fillRef idx="3">
+            <a:schemeClr val="accent1"/>
+          </a:fillRef>
+          <a:effectRef idx="2">
+            <a:schemeClr val="accent1"/>
+          </a:effectRef>
+          <a:fontRef idx="minor">
+            <a:schemeClr val="lt1"/>
+          </a:fontRef>
+        </p:style>
+        <p:txBody>
+          <a:bodyPr rtlCol="0" anchor="ctr"/>
+          <a:lstStyle/>
+          <a:p>
+            <a:pPr algn="ctr"/>
+            <a:endParaRPr/>
+          </a:p>
+        </p:txBody>
+      </p:sp>
+      <p:sp>
+        <p:nvSpPr>
+          <p:cNvPr id="20" name="TextBox 7">
+            <a:extLst>
+              <a:ext uri="{FF2B5EF4-FFF2-40B4-BE49-F238E27FC236}">
+                <a16:creationId xmlns:a16="http://schemas.microsoft.com/office/drawing/2014/main" id="{A7A9009C-6D88-9D23-32E6-AF9CE287D70C}"/>
+              </a:ext>
+            </a:extLst>
+          </p:cNvPr>
+          <p:cNvSpPr txBox="1"/>
+          <p:nvPr/>
+        </p:nvSpPr>
+        <p:spPr>
+          <a:xfrm>
+            <a:off x="878393" y="4752031"/>
+            <a:ext cx="3328356" cy="1092607"/>
+          </a:xfrm>
+          <a:prstGeom prst="rect">
+            <a:avLst/>
+          </a:prstGeom>
+          <a:noFill/>
+        </p:spPr>
+        <p:txBody>
+          <a:bodyPr wrap="square">
+            <a:spAutoFit/>
+          </a:bodyPr>
+          <a:lstStyle/>
+          <a:p>
+            <a:pPr>
+              <a:defRPr sz="1200" b="1">
+                <a:solidFill>
+                  <a:srgbClr val="2366AA"/>
+                </a:solidFill>
+              </a:defRPr>
+            </a:pPr>
+            <a:r>
+              <a:rPr lang="es-MX" dirty="0">
+                <a:solidFill>
+                  <a:schemeClr val="accent6"/>
+                </a:solidFill>
+              </a:rPr>
+              <a:t>IMPLICACIÓN</a:t>
+            </a:r>
+            <a:endParaRPr dirty="0">
+              <a:solidFill>
+                <a:schemeClr val="accent6"/>
+              </a:solidFill>
+            </a:endParaRPr>
+          </a:p>
+          <a:p>
+            <a:pPr algn="just">
+              <a:spcBef>
+                <a:spcPts val="600"/>
+              </a:spcBef>
+              <a:defRPr sz="1200">
+                <a:solidFill>
+                  <a:srgbClr val="232B32"/>
+                </a:solidFill>
+              </a:defRPr>
+            </a:pPr>
+            <a:r>
+              <a:rPr lang="es-CO" sz="1200" dirty="0">
+                <a:solidFill>
+                  <a:srgbClr val="232B32"/>
+                </a:solidFill>
+              </a:rPr>
+              <a:t>La baja concentración por proveedor no elimina riesgos de seguimiento, ya que el valor contratado sí se concentra fuertemente en ciertas modalidades y tipos de contrato.</a:t>
+            </a:r>
+            <a:endParaRPr dirty="0"/>
+          </a:p>
+        </p:txBody>
+      </p:sp>
     </p:spTree>
   </p:cSld>
   <p:clrMapOvr>

</xml_diff>